<commit_message>
Ship Firebase care spaces and verified narrated submission demo
</commit_message>
<xml_diff>
--- a/submission/looplight-pitch.pptx
+++ b/submission/looplight-pitch.pptx
@@ -2,19 +2,19 @@
 <file path=ppt/presentation.xml><?xml version="1.0" encoding="utf-8"?>
 <p:presentation xmlns:p="http://schemas.openxmlformats.org/presentationml/2006/main">
   <p:sldMasterIdLst>
-    <p:sldMasterId xmlns:r="http://schemas.openxmlformats.org/officeDocument/2006/relationships" id="2147483648" r:id="R4d57a42a27e84a7d"/>
+    <p:sldMasterId xmlns:r="http://schemas.openxmlformats.org/officeDocument/2006/relationships" id="2147483648" r:id="Rc025c0b442464c28"/>
   </p:sldMasterIdLst>
   <p:notesMasterIdLst>
-    <p:notesMasterId xmlns:r="http://schemas.openxmlformats.org/officeDocument/2006/relationships" r:id="R78082e68a8944a97"/>
+    <p:notesMasterId xmlns:r="http://schemas.openxmlformats.org/officeDocument/2006/relationships" r:id="R192886f31aed44a9"/>
   </p:notesMasterIdLst>
   <p:sldIdLst>
-    <p:sldId xmlns:r="http://schemas.openxmlformats.org/officeDocument/2006/relationships" id="256" r:id="R3a3c3dc720844665"/>
-    <p:sldId xmlns:r="http://schemas.openxmlformats.org/officeDocument/2006/relationships" id="257" r:id="R1917dedb6640496a"/>
-    <p:sldId xmlns:r="http://schemas.openxmlformats.org/officeDocument/2006/relationships" id="258" r:id="R9f890ac033c34c15"/>
-    <p:sldId xmlns:r="http://schemas.openxmlformats.org/officeDocument/2006/relationships" id="259" r:id="Rd427ea66b9e04e8f"/>
-    <p:sldId xmlns:r="http://schemas.openxmlformats.org/officeDocument/2006/relationships" id="260" r:id="R7f9f69b560fa4aef"/>
-    <p:sldId xmlns:r="http://schemas.openxmlformats.org/officeDocument/2006/relationships" id="261" r:id="R0b9025c8ca8348e4"/>
-    <p:sldId xmlns:r="http://schemas.openxmlformats.org/officeDocument/2006/relationships" id="262" r:id="R070f1f718e5a4373"/>
+    <p:sldId xmlns:r="http://schemas.openxmlformats.org/officeDocument/2006/relationships" id="256" r:id="R37ddd93316264e8c"/>
+    <p:sldId xmlns:r="http://schemas.openxmlformats.org/officeDocument/2006/relationships" id="257" r:id="R7f268efa88c646ca"/>
+    <p:sldId xmlns:r="http://schemas.openxmlformats.org/officeDocument/2006/relationships" id="258" r:id="Rc0e1826ea402485a"/>
+    <p:sldId xmlns:r="http://schemas.openxmlformats.org/officeDocument/2006/relationships" id="259" r:id="Rb855fd99364e49f9"/>
+    <p:sldId xmlns:r="http://schemas.openxmlformats.org/officeDocument/2006/relationships" id="260" r:id="R1a38f055581c47e0"/>
+    <p:sldId xmlns:r="http://schemas.openxmlformats.org/officeDocument/2006/relationships" id="261" r:id="Rff0920b9f292442b"/>
+    <p:sldId xmlns:r="http://schemas.openxmlformats.org/officeDocument/2006/relationships" id="262" r:id="Rd0687f4a058043dc"/>
   </p:sldIdLst>
   <p:sldSz cx="12192000" cy="6858000"/>
   <p:notesSz cx="6858000" cy="9144000"/>
@@ -448,7 +448,17 @@
           <a:lstStyle xmlns:a="http://schemas.openxmlformats.org/drawingml/2006/main"/>
           <a:p xmlns:a="http://schemas.openxmlformats.org/drawingml/2006/main">
             <a:r>
-              <a:t>Looplight is Shivam Gupta's UnivaBio project, built with AI-assisted development. The product is a working MVP for synthetic demonstration, with no clinical validation or claimed health outcome. Open with the family scenario, then demonstrate the real application. No external visual assets are used on this slide.</a:t>
+              <a:t>Looplight is Shivam Gupta's UnivaBio project, built with AI-assisted development. This is a prototype tested with synthetic data. Demonstration records are fictional. The final Firebase deployment URL and screenshots were supplied by the build owner. Do not claim clinical validation or proven health benefit.</a:t>
+            </a:r>
+          </a:p>
+          <a:p xmlns:a="http://schemas.openxmlformats.org/drawingml/2006/main">
+            <a:r>
+              <a:t/>
+            </a:r>
+          </a:p>
+          <a:p xmlns:a="http://schemas.openxmlformats.org/drawingml/2006/main">
+            <a:r>
+              <a:t>Release status: ready. The build owner reports 57 live Firebase checks passed on synthetic records, with owner isolation and persistence verified. Google sign-in and an edited demo surviving account save and refresh passed GUI checks. Additional UI review continues. These checks are not clinical validation or a guarantee that all defects have been found.</a:t>
             </a:r>
           </a:p>
         </p:txBody>
@@ -518,7 +528,17 @@
           <a:lstStyle xmlns:a="http://schemas.openxmlformats.org/drawingml/2006/main"/>
           <a:p xmlns:a="http://schemas.openxmlformats.org/drawingml/2006/main">
             <a:r>
-              <a:t>Source: Roy CL et al. Patient safety concerns arising from test results that return after hospital discharge. Ann Intern Med. 2005. https://pubmed.ncbi.nlm.nih.gov/16027454/ . The study covers discharges in 2004 at two academic hospitals. 41% refers to patients with results returning after discharge. Do not describe this as today's global rate. The 2025 SAFER Guides include a dedicated Test Results Reporting and Follow-Up guide: https://healthit.gov/resources/2025-safer-guide-test-results-reporting-and-follow-up/ . This context supports studying the workflow, not an endorsement or claim of Looplight benefit. Anita and Maya are synthetic demonstration characters.</a:t>
+              <a:t>Roy CL et al. Patient safety concerns arising from test results that return after hospital discharge. Ann Intern Med. 2005. https://pubmed.ncbi.nlm.nih.gov/16027454/ . The discharges were in 2004 at two academic hospitals. This is historical workflow context, not today's global prevalence. The 2025 SAFER Test Results Reporting and Follow-Up guide provides additional workflow context: https://healthit.gov/resources/2025-safer-guide-test-results-reporting-and-follow-up/ . Neither source endorses Looplight or establishes its benefit.</a:t>
+            </a:r>
+          </a:p>
+          <a:p xmlns:a="http://schemas.openxmlformats.org/drawingml/2006/main">
+            <a:r>
+              <a:t/>
+            </a:r>
+          </a:p>
+          <a:p xmlns:a="http://schemas.openxmlformats.org/drawingml/2006/main">
+            <a:r>
+              <a:t>Release status: ready. The build owner reports 57 live Firebase checks passed on synthetic records, with owner isolation and persistence verified. Google sign-in and an edited demo surviving account save and refresh passed GUI checks. Additional UI review continues. These checks are not clinical validation or a guarantee that all defects have been found.</a:t>
             </a:r>
           </a:p>
         </p:txBody>
@@ -588,7 +608,17 @@
           <a:lstStyle xmlns:a="http://schemas.openxmlformats.org/drawingml/2006/main"/>
           <a:p xmlns:a="http://schemas.openxmlformats.org/drawingml/2006/main">
             <a:r>
-              <a:t>Verified application screenshot supplied by the build owner, captured from the running Looplight care board with fictional Anita/Maya data. The original image remains embedded and the slide crop removes blank right and bottom space. Product UI: Add discharge notes &gt; Anita’s discharge &gt; Find the open loops; Needs review; Check details &gt; Who will keep track of this? &gt; Confirm this follow-up. Engine hybrid-1.2. The app supports pasted text/text-based PDFs, whole-source sentence review, human-confirmed tasks, sign-in and saved plans, Visit brief printing, Calendar file export, and JSON export in the account. Source PDF bytes are not retained; extracted text is saved. Browser/API QA was still in progress when the screenshot was supplied.</a:t>
+              <a:t>The desktop and mobile captures show the real Firebase application using fictional Anita/Maya data. Original screenshot bytes are retained with editable native crops. The app accepts pasted text and text-based PDFs, exposes all source sentences, and requires task confirmation before tracking. The current demo can be saved to an account with its edits preserved. Imported PDF bytes are not retained; extracted text forms the source record. Final capture controls include Add discharge notes, Review the whole note, and the source-linked follow-up cards.</a:t>
+            </a:r>
+          </a:p>
+          <a:p xmlns:a="http://schemas.openxmlformats.org/drawingml/2006/main">
+            <a:r>
+              <a:t/>
+            </a:r>
+          </a:p>
+          <a:p xmlns:a="http://schemas.openxmlformats.org/drawingml/2006/main">
+            <a:r>
+              <a:t>Release status: ready. The build owner reports 57 live Firebase checks passed on synthetic records, with owner isolation and persistence verified. Google sign-in and an edited demo surviving account save and refresh passed GUI checks. Additional UI review continues. These checks are not clinical validation or a guarantee that all defects have been found.</a:t>
             </a:r>
           </a:p>
         </p:txBody>
@@ -658,7 +688,17 @@
           <a:lstStyle xmlns:a="http://schemas.openxmlformats.org/drawingml/2006/main"/>
           <a:p xmlns:a="http://schemas.openxmlformats.org/drawingml/2006/main">
             <a:r>
-              <a:t>The app separates receipt of a result from the user's report that a clinician reviewed it. A named tracker is the person following up, not proof that a clinician accepted treatment responsibility. Closing a task is an administrative record of the reported outcome, not medical clearance or independently verified clinical evidence. The source text, changes, and reported outcome remain inspectable. Original uploaded PDF bytes are not retained. Show the actual transition and history in the application.</a:t>
+              <a:t>Follow-up transition logic runs in the browser. Firestore rules validate ownership, immutable source fields, versions, and quotas; they do not independently validate the full follow-up transition workflow. The user records clinician review and outcome. A clinician name is not verified identity or signed attestation. A tracker is the person following up, not an assignment of clinical responsibility. The actual Firebase result-detail capture shows source evidence and unresolved details, not clinician-verified evidence.</a:t>
+            </a:r>
+          </a:p>
+          <a:p xmlns:a="http://schemas.openxmlformats.org/drawingml/2006/main">
+            <a:r>
+              <a:t/>
+            </a:r>
+          </a:p>
+          <a:p xmlns:a="http://schemas.openxmlformats.org/drawingml/2006/main">
+            <a:r>
+              <a:t>Release status: ready. The build owner reports 57 live Firebase checks passed on synthetic records, with owner isolation and persistence verified. Google sign-in and an edited demo surviving account save and refresh passed GUI checks. Additional UI review continues. These checks are not clinical validation or a guarantee that all defects have been found.</a:t>
             </a:r>
           </a:p>
         </p:txBody>
@@ -728,7 +768,17 @@
           <a:lstStyle xmlns:a="http://schemas.openxmlformats.org/drawingml/2006/main"/>
           <a:p xmlns:a="http://schemas.openxmlformats.org/drawingml/2006/main">
             <a:r>
-              <a:t>Project evaluation supplied during development: 225 original synthetic training examples; 50 separate synthetic challenge examples; raw 5-way accuracy 0.82; macro F1 approximately 0.816; configured threshold abstains on 44/50. Raw accuracy is the argmax classification score before abstention and does not describe autonomous clinical performance. This is not a real patient test set, not a document-level missed-obligation evaluation, and not a health-outcome study. All sentences remain available for human review. The build owner reconfirmed these unchanged metrics alongside engine hybrid-1.2. The model needs no paid inference API.</a:t>
+              <a:t>Historical development report, not a new Firebase deployment benchmark: 20 synthetic document fixtures, 44 expected actions, 34 proposals, 33 matches. Precision 33/34 = 97.1%; recall 33/44 = 75%. The initial development result was 84.2% precision and 72.7% recall; fixes were evaluated on the same known fixtures. This is not an untouched holdout, clinician-annotated real-world evaluation, or evidence of health benefit. No model uplift over rules alone has been demonstrated. Separate classifier evidence, if judges ask: 225 original synthetic training examples, 50 separately authored synthetic challenge examples, 82% raw five-category accuracy, macro F1 about 0.816, 44/50 abstentions. Do not conflate sentence classification with document-level extraction or clinical safety. Firebase deployment checks are separate from this historical extraction evaluation.</a:t>
+            </a:r>
+          </a:p>
+          <a:p xmlns:a="http://schemas.openxmlformats.org/drawingml/2006/main">
+            <a:r>
+              <a:t/>
+            </a:r>
+          </a:p>
+          <a:p xmlns:a="http://schemas.openxmlformats.org/drawingml/2006/main">
+            <a:r>
+              <a:t>Release status: ready. The build owner reports 57 live Firebase checks passed on synthetic records, with owner isolation and persistence verified. Google sign-in and an edited demo surviving account save and refresh passed GUI checks. Additional UI review continues. These checks are not clinical validation or a guarantee that all defects have been found.</a:t>
             </a:r>
           </a:p>
         </p:txBody>
@@ -798,7 +848,17 @@
           <a:lstStyle xmlns:a="http://schemas.openxmlformats.org/drawingml/2006/main"/>
           <a:p xmlns:a="http://schemas.openxmlformats.org/drawingml/2006/main">
             <a:r>
-              <a:t>Business hypotheses, not customer research: $149 per coordinator account/month for 100 care episodes, with a proposed $1 extra episode price. Initial buyer hypothesis: a primary-care or transitions coordinator. The current MVP uses a single coordinator account. Shared team workflows would be future work. Patients and caregivers would use the plan free. Staff-time arithmetic: 100 × 5/60 × $35 = $291.67 per month. No measured savings or willingness to pay exists. The model inference API fee is zero in the local-classifier approach, but hosting, database, support, clinical/security review, and governance costs remain. Competitors overlap: https://www.seamless.md/ , https://www.memorahealth.com/ , https://www.eonhealth.com/platform , https://welkinhealth.com/ . Do not claim exclusive features or a demonstrated moat. Proposed narrow position: an upload-first, source-reviewable follow-up ledger without initial EHR integration.</a:t>
+              <a:t>The price and savings inputs are hypotheses, not customer research. $149 per coordinator account/month for 100 episodes is a proposed experiment. No revenue, willingness-to-pay evidence, customer validation, or observed time saving is claimed. Five minutes x 100 / 60 x $35 = $291.67 before review and implementation costs. Inference runs in the browser without a paid model API; hosting, storage, support, security review, clinical governance, and bandwidth remain costs. Shared team workflows are future work. Related products include SeamlessMD, Memora/Commure, Eon, and care-management platforms. Source grounding alone is not a demonstrated moat.</a:t>
+            </a:r>
+          </a:p>
+          <a:p xmlns:a="http://schemas.openxmlformats.org/drawingml/2006/main">
+            <a:r>
+              <a:t/>
+            </a:r>
+          </a:p>
+          <a:p xmlns:a="http://schemas.openxmlformats.org/drawingml/2006/main">
+            <a:r>
+              <a:t>Release status: ready. The build owner reports 57 live Firebase checks passed on synthetic records, with owner isolation and persistence verified. Google sign-in and an edited demo surviving account save and refresh passed GUI checks. Additional UI review continues. These checks are not clinical validation or a guarantee that all defects have been found.</a:t>
             </a:r>
           </a:p>
         </p:txBody>
@@ -868,7 +928,17 @@
           <a:lstStyle xmlns:a="http://schemas.openxmlformats.org/drawingml/2006/main"/>
           <a:p xmlns:a="http://schemas.openxmlformats.org/drawingml/2006/main">
             <a:r>
-              <a:t>Proposed next work: interviews and retrospective review under appropriate data governance, clinician-annotated documents, then supervised prospective evaluation. Primary process measures: missed obligations and misleading extra tasks at document level, staff preparation time, review burden, named tracker/date completeness, and time to reported resolution. A small pilot cannot establish a causal reduction in readmissions. The app cannot recover care obligations absent from source records. It does not diagnose, interpret results, prescribe treatment, or determine patient safety. The code repository is the stable handoff link. The hosted app is private pending access verification, so this slide does not claim public availability. Credit: Shivam Gupta, founder and builder, with AI-assisted development.</a:t>
+              <a:t>Firebase Hosting, Firebase Authentication, and Cloud Firestore replace the previous hosting/account stack. Model inference, task extraction, and workflow transitions execute in the browser. Firestore security rules enforce ownership, immutable source fields, versions, and quotas. They do not provide independent server-side clinical transition validation. The current demo-save flow preserves edits in the account. The build owner supplied 57 passed live Firebase checks and verified owner isolation and persistence. Google sign-in and edited-demo account-save persistence were verified in the GUI. Additional UI review continues. No flawless-operation claim is made. Proposed next work is a governed retrospective review with clinician annotation, followed by a supervised pilot. A small pilot cannot prove a causal reduction in readmissions.</a:t>
+            </a:r>
+          </a:p>
+          <a:p xmlns:a="http://schemas.openxmlformats.org/drawingml/2006/main">
+            <a:r>
+              <a:t/>
+            </a:r>
+          </a:p>
+          <a:p xmlns:a="http://schemas.openxmlformats.org/drawingml/2006/main">
+            <a:r>
+              <a:t>Release status: ready. The build owner reports 57 live Firebase checks passed on synthetic records, with owner isolation and persistence verified. Google sign-in and an edited demo surviving account save and refresh passed GUI checks. Additional UI review continues. These checks are not clinical validation or a guarantee that all defects have been found.</a:t>
             </a:r>
           </a:p>
         </p:txBody>
@@ -936,7 +1006,7 @@
   </p:cSld>
   <p:clrMap bg1="lt1" tx1="dk1" bg2="lt2" tx2="dk2" accent1="accent1" accent2="accent2" accent3="accent3" accent4="accent4" accent5="accent5" accent6="accent6" hlink="hlink" folHlink="folHlink"/>
   <p:sldLayoutIdLst>
-    <p:sldLayoutId xmlns:r="http://schemas.openxmlformats.org/officeDocument/2006/relationships" id="2147483649" r:id="Rd9bf41b404854606"/>
+    <p:sldLayoutId xmlns:r="http://schemas.openxmlformats.org/officeDocument/2006/relationships" id="2147483649" r:id="R3d36bf3ddd5d4424"/>
   </p:sldLayoutIdLst>
   <p:txStyles>
     <p:titleStyle>
@@ -1484,10 +1554,10 @@
       </p:grpSpPr>
       <p:sp>
         <p:nvSpPr>
-          <p:cNvPr id="6" name="text-1">
+          <p:cNvPr id="7" name="text-1">
             <a:extLst xmlns:a="http://schemas.openxmlformats.org/drawingml/2006/main">
               <a:ext uri="{FF2B5EF4-FFF2-40B4-BE49-F238E27FC236}">
-                <a16:creationId xmlns:a16="http://schemas.microsoft.com/office/drawing/2014/main" id="{8E35F1E5-C70B-437A-B404-22C922FE2291}"/>
+                <a16:creationId xmlns:a16="http://schemas.microsoft.com/office/drawing/2014/main" id="{14B185A3-639A-410C-AE2D-E8F77221674C}"/>
               </a:ext>
             </a:extLst>
           </p:cNvPr>
@@ -1544,7 +1614,7 @@
           <p:cNvPr id="2" name="text-2">
             <a:extLst xmlns:a="http://schemas.openxmlformats.org/drawingml/2006/main">
               <a:ext uri="{FF2B5EF4-FFF2-40B4-BE49-F238E27FC236}">
-                <a16:creationId xmlns:a16="http://schemas.microsoft.com/office/drawing/2014/main" id="{1BD995E5-9631-4CFD-A223-45B92F240268}"/>
+                <a16:creationId xmlns:a16="http://schemas.microsoft.com/office/drawing/2014/main" id="{00A20B2B-6FB3-4111-BF36-0461AFE9610F}"/>
               </a:ext>
             </a:extLst>
           </p:cNvPr>
@@ -1555,7 +1625,7 @@
         </p:nvSpPr>
         <p:spPr>
           <a:xfrm xmlns:a="http://schemas.openxmlformats.org/drawingml/2006/main">
-            <a:off x="647700" y="1885950"/>
+            <a:off x="647700" y="1809750"/>
             <a:ext cx="10820400" cy="2066925"/>
           </a:xfrm>
           <a:prstGeom xmlns:a="http://schemas.openxmlformats.org/drawingml/2006/main" prst="rect">
@@ -1624,7 +1694,7 @@
           <p:cNvPr id="3" name="text-3">
             <a:extLst xmlns:a="http://schemas.openxmlformats.org/drawingml/2006/main">
               <a:ext uri="{FF2B5EF4-FFF2-40B4-BE49-F238E27FC236}">
-                <a16:creationId xmlns:a16="http://schemas.microsoft.com/office/drawing/2014/main" id="{6770EF11-4E43-47CF-9B84-61AC9B3809AD}"/>
+                <a16:creationId xmlns:a16="http://schemas.microsoft.com/office/drawing/2014/main" id="{3C5E92A1-744F-484B-BA2E-A10A8D2186B3}"/>
               </a:ext>
             </a:extLst>
           </p:cNvPr>
@@ -1635,7 +1705,7 @@
         </p:nvSpPr>
         <p:spPr>
           <a:xfrm xmlns:a="http://schemas.openxmlformats.org/drawingml/2006/main">
-            <a:off x="685800" y="4381500"/>
+            <a:off x="685800" y="4314825"/>
             <a:ext cx="10096500" cy="723900"/>
           </a:xfrm>
           <a:prstGeom xmlns:a="http://schemas.openxmlformats.org/drawingml/2006/main" prst="rect">
@@ -1681,7 +1751,7 @@
           <p:cNvPr id="4" name="text-4">
             <a:extLst xmlns:a="http://schemas.openxmlformats.org/drawingml/2006/main">
               <a:ext uri="{FF2B5EF4-FFF2-40B4-BE49-F238E27FC236}">
-                <a16:creationId xmlns:a16="http://schemas.microsoft.com/office/drawing/2014/main" id="{29927AA3-77B8-4C4D-98CE-12B6533C907E}"/>
+                <a16:creationId xmlns:a16="http://schemas.microsoft.com/office/drawing/2014/main" id="{3144A68F-CEE0-44C0-8FB7-88F5FFE30229}"/>
               </a:ext>
             </a:extLst>
           </p:cNvPr>
@@ -1692,8 +1762,8 @@
         </p:nvSpPr>
         <p:spPr>
           <a:xfrm xmlns:a="http://schemas.openxmlformats.org/drawingml/2006/main">
-            <a:off x="685800" y="5848350"/>
-            <a:ext cx="6667500" cy="304800"/>
+            <a:off x="685800" y="5219700"/>
+            <a:ext cx="9906000" cy="390525"/>
           </a:xfrm>
           <a:prstGeom xmlns:a="http://schemas.openxmlformats.org/drawingml/2006/main" prst="rect">
             <a:avLst/>
@@ -1710,25 +1780,25 @@
           <a:lstStyle xmlns:a="http://schemas.openxmlformats.org/drawingml/2006/main"/>
           <a:p xmlns:a="http://schemas.openxmlformats.org/drawingml/2006/main">
             <a:pPr>
-              <a:defRPr sz="1725" b="1">
-                <a:solidFill>
-                  <a:srgbClr val="FFFFFF"/>
-                </a:solidFill>
-                <a:latin typeface="Noto Sans"/>
-                <a:ea typeface="Noto Sans"/>
-                <a:cs typeface="Noto Sans"/>
-              </a:defRPr>
-            </a:pPr>
-            <a:r>
-              <a:rPr sz="1725" b="1">
-                <a:solidFill>
-                  <a:srgbClr val="FFFFFF"/>
-                </a:solidFill>
-                <a:latin typeface="Noto Sans"/>
-                <a:ea typeface="Noto Sans"/>
-                <a:cs typeface="Noto Sans"/>
-              </a:rPr>
-              <a:t>Shivam Gupta</a:t>
+              <a:defRPr sz="2025" b="1">
+                <a:solidFill>
+                  <a:srgbClr val="C7F578"/>
+                </a:solidFill>
+                <a:latin typeface="Noto Sans"/>
+                <a:ea typeface="Noto Sans"/>
+                <a:cs typeface="Noto Sans"/>
+              </a:defRPr>
+            </a:pPr>
+            <a:r>
+              <a:rPr sz="2025" b="1">
+                <a:solidFill>
+                  <a:srgbClr val="C7F578"/>
+                </a:solidFill>
+                <a:latin typeface="Noto Sans"/>
+                <a:ea typeface="Noto Sans"/>
+                <a:cs typeface="Noto Sans"/>
+              </a:rPr>
+              <a:t>looplight-care.web.app</a:t>
             </a:r>
           </a:p>
         </p:txBody>
@@ -1738,7 +1808,7 @@
           <p:cNvPr id="5" name="text-5">
             <a:extLst xmlns:a="http://schemas.openxmlformats.org/drawingml/2006/main">
               <a:ext uri="{FF2B5EF4-FFF2-40B4-BE49-F238E27FC236}">
-                <a16:creationId xmlns:a16="http://schemas.microsoft.com/office/drawing/2014/main" id="{836B671E-E10E-46E5-89E2-099939D36546}"/>
+                <a16:creationId xmlns:a16="http://schemas.microsoft.com/office/drawing/2014/main" id="{A3266F44-E523-4503-BAF7-8265BAF98E80}"/>
               </a:ext>
             </a:extLst>
           </p:cNvPr>
@@ -1749,8 +1819,8 @@
         </p:nvSpPr>
         <p:spPr>
           <a:xfrm xmlns:a="http://schemas.openxmlformats.org/drawingml/2006/main">
-            <a:off x="685800" y="6200775"/>
-            <a:ext cx="10477500" cy="266700"/>
+            <a:off x="685800" y="5895975"/>
+            <a:ext cx="6667500" cy="304800"/>
           </a:xfrm>
           <a:prstGeom xmlns:a="http://schemas.openxmlformats.org/drawingml/2006/main" prst="rect">
             <a:avLst/>
@@ -1767,6 +1837,63 @@
           <a:lstStyle xmlns:a="http://schemas.openxmlformats.org/drawingml/2006/main"/>
           <a:p xmlns:a="http://schemas.openxmlformats.org/drawingml/2006/main">
             <a:pPr>
+              <a:defRPr sz="1725" b="1">
+                <a:solidFill>
+                  <a:srgbClr val="FFFFFF"/>
+                </a:solidFill>
+                <a:latin typeface="Noto Sans"/>
+                <a:ea typeface="Noto Sans"/>
+                <a:cs typeface="Noto Sans"/>
+              </a:defRPr>
+            </a:pPr>
+            <a:r>
+              <a:rPr sz="1725" b="1">
+                <a:solidFill>
+                  <a:srgbClr val="FFFFFF"/>
+                </a:solidFill>
+                <a:latin typeface="Noto Sans"/>
+                <a:ea typeface="Noto Sans"/>
+                <a:cs typeface="Noto Sans"/>
+              </a:rPr>
+              <a:t>Shivam Gupta</a:t>
+            </a:r>
+          </a:p>
+        </p:txBody>
+      </p:sp>
+      <p:sp>
+        <p:nvSpPr>
+          <p:cNvPr id="6" name="text-6">
+            <a:extLst xmlns:a="http://schemas.openxmlformats.org/drawingml/2006/main">
+              <a:ext uri="{FF2B5EF4-FFF2-40B4-BE49-F238E27FC236}">
+                <a16:creationId xmlns:a16="http://schemas.microsoft.com/office/drawing/2014/main" id="{5B352C17-9A83-4C7C-AEF1-010D8E8D3C32}"/>
+              </a:ext>
+            </a:extLst>
+          </p:cNvPr>
+          <p:cNvSpPr>
+            <a:spLocks xmlns:a="http://schemas.openxmlformats.org/drawingml/2006/main" noGrp="1"/>
+          </p:cNvSpPr>
+          <p:nvPr/>
+        </p:nvSpPr>
+        <p:spPr>
+          <a:xfrm xmlns:a="http://schemas.openxmlformats.org/drawingml/2006/main">
+            <a:off x="685800" y="6229350"/>
+            <a:ext cx="10477500" cy="266700"/>
+          </a:xfrm>
+          <a:prstGeom xmlns:a="http://schemas.openxmlformats.org/drawingml/2006/main" prst="rect">
+            <a:avLst/>
+          </a:prstGeom>
+          <a:noFill xmlns:a="http://schemas.openxmlformats.org/drawingml/2006/main"/>
+          <a:ln xmlns:a="http://schemas.openxmlformats.org/drawingml/2006/main" w="0">
+            <a:noFill/>
+          </a:ln>
+        </p:spPr>
+        <p:txBody>
+          <a:bodyPr xmlns:a="http://schemas.openxmlformats.org/drawingml/2006/main" wrap="square" lIns="0" tIns="0" rIns="0" bIns="0" anchor="t">
+            <a:noAutofit/>
+          </a:bodyPr>
+          <a:lstStyle xmlns:a="http://schemas.openxmlformats.org/drawingml/2006/main"/>
+          <a:p xmlns:a="http://schemas.openxmlformats.org/drawingml/2006/main">
+            <a:pPr>
               <a:defRPr sz="1350" b="0">
                 <a:solidFill>
                   <a:srgbClr val="DCE4EF"/>
@@ -1785,7 +1912,7 @@
                 <a:ea typeface="Noto Sans"/>
                 <a:cs typeface="Noto Sans"/>
               </a:rPr>
-              <a:t>Founder &amp; builder   /   Built with AI-assisted development</a:t>
+              <a:t>Founder &amp; builder / Built with AI-assisted development</a:t>
             </a:r>
           </a:p>
         </p:txBody>
@@ -1793,7 +1920,7 @@
     </p:spTree>
     <p:extLst>
       <p:ext uri="{BB962C8B-B14F-4D97-AF65-F5344CB8AC3E}">
-        <p14:creationId xmlns:p14="http://schemas.microsoft.com/office/powerpoint/2010/main" val="667990988"/>
+        <p14:creationId xmlns:p14="http://schemas.microsoft.com/office/powerpoint/2010/main" val="917848403"/>
       </p:ext>
     </p:extLst>
   </p:cSld>
@@ -1821,10 +1948,10 @@
       </p:grpSpPr>
       <p:sp>
         <p:nvSpPr>
-          <p:cNvPr id="8" name="text-6">
+          <p:cNvPr id="8" name="text-7">
             <a:extLst xmlns:a="http://schemas.openxmlformats.org/drawingml/2006/main">
               <a:ext uri="{FF2B5EF4-FFF2-40B4-BE49-F238E27FC236}">
-                <a16:creationId xmlns:a16="http://schemas.microsoft.com/office/drawing/2014/main" id="{A75DA219-B73D-4E26-9D3A-4EF32AB61FE1}"/>
+                <a16:creationId xmlns:a16="http://schemas.microsoft.com/office/drawing/2014/main" id="{F44BF6D3-956A-47F2-ADB1-A6BE1AE1ACF6}"/>
               </a:ext>
             </a:extLst>
           </p:cNvPr>
@@ -1878,10 +2005,10 @@
       </p:sp>
       <p:sp>
         <p:nvSpPr>
-          <p:cNvPr id="2" name="text-7">
+          <p:cNvPr id="2" name="text-8">
             <a:extLst xmlns:a="http://schemas.openxmlformats.org/drawingml/2006/main">
               <a:ext uri="{FF2B5EF4-FFF2-40B4-BE49-F238E27FC236}">
-                <a16:creationId xmlns:a16="http://schemas.microsoft.com/office/drawing/2014/main" id="{BB7118A6-3193-41A1-8375-F2E2EE5BB45A}"/>
+                <a16:creationId xmlns:a16="http://schemas.microsoft.com/office/drawing/2014/main" id="{ECA072D5-9872-4CB1-A368-28446D0EC3C5}"/>
               </a:ext>
             </a:extLst>
           </p:cNvPr>
@@ -1981,10 +2108,10 @@
       </p:sp>
       <p:sp>
         <p:nvSpPr>
-          <p:cNvPr id="3" name="text-8">
+          <p:cNvPr id="3" name="text-9">
             <a:extLst xmlns:a="http://schemas.openxmlformats.org/drawingml/2006/main">
               <a:ext uri="{FF2B5EF4-FFF2-40B4-BE49-F238E27FC236}">
-                <a16:creationId xmlns:a16="http://schemas.microsoft.com/office/drawing/2014/main" id="{4367215A-F646-4A6B-BE3A-42AA7AD09A53}"/>
+                <a16:creationId xmlns:a16="http://schemas.microsoft.com/office/drawing/2014/main" id="{468DAEBD-F937-49CD-969E-9264E7EE3A7E}"/>
               </a:ext>
             </a:extLst>
           </p:cNvPr>
@@ -2061,10 +2188,10 @@
       </p:sp>
       <p:sp>
         <p:nvSpPr>
-          <p:cNvPr id="4" name="text-9">
+          <p:cNvPr id="4" name="text-10">
             <a:extLst xmlns:a="http://schemas.openxmlformats.org/drawingml/2006/main">
               <a:ext uri="{FF2B5EF4-FFF2-40B4-BE49-F238E27FC236}">
-                <a16:creationId xmlns:a16="http://schemas.microsoft.com/office/drawing/2014/main" id="{CE538B3B-D9E1-4E61-B6CE-DBAE348908BA}"/>
+                <a16:creationId xmlns:a16="http://schemas.microsoft.com/office/drawing/2014/main" id="{476C09B9-A275-4AA2-ADD2-BDDCA1F1E717}"/>
               </a:ext>
             </a:extLst>
           </p:cNvPr>
@@ -2118,10 +2245,10 @@
       </p:sp>
       <p:sp>
         <p:nvSpPr>
-          <p:cNvPr id="5" name="text-10">
+          <p:cNvPr id="5" name="text-11">
             <a:extLst xmlns:a="http://schemas.openxmlformats.org/drawingml/2006/main">
               <a:ext uri="{FF2B5EF4-FFF2-40B4-BE49-F238E27FC236}">
-                <a16:creationId xmlns:a16="http://schemas.microsoft.com/office/drawing/2014/main" id="{051F2388-BC4C-4008-8F52-756560DB860E}"/>
+                <a16:creationId xmlns:a16="http://schemas.microsoft.com/office/drawing/2014/main" id="{5DA316FF-33E3-44F3-8280-4DDE6CD09C7C}"/>
               </a:ext>
             </a:extLst>
           </p:cNvPr>
@@ -2198,10 +2325,10 @@
       </p:sp>
       <p:sp>
         <p:nvSpPr>
-          <p:cNvPr id="6" name="text-11">
+          <p:cNvPr id="6" name="text-12">
             <a:extLst xmlns:a="http://schemas.openxmlformats.org/drawingml/2006/main">
               <a:ext uri="{FF2B5EF4-FFF2-40B4-BE49-F238E27FC236}">
-                <a16:creationId xmlns:a16="http://schemas.microsoft.com/office/drawing/2014/main" id="{CB87D652-E5D3-4C2A-AD1E-90B81E0306EC}"/>
+                <a16:creationId xmlns:a16="http://schemas.microsoft.com/office/drawing/2014/main" id="{3DC30DFE-7A92-4172-8B7A-78785EEB68A8}"/>
               </a:ext>
             </a:extLst>
           </p:cNvPr>
@@ -2324,10 +2451,10 @@
       </p:sp>
       <p:sp>
         <p:nvSpPr>
-          <p:cNvPr id="7" name="text-12">
+          <p:cNvPr id="7" name="text-13">
             <a:extLst xmlns:a="http://schemas.openxmlformats.org/drawingml/2006/main">
               <a:ext uri="{FF2B5EF4-FFF2-40B4-BE49-F238E27FC236}">
-                <a16:creationId xmlns:a16="http://schemas.microsoft.com/office/drawing/2014/main" id="{AAF9B67A-8EF5-46B9-88E2-57D94A05B10B}"/>
+                <a16:creationId xmlns:a16="http://schemas.microsoft.com/office/drawing/2014/main" id="{FB6CB549-5597-4271-AAB3-DB02D7216772}"/>
               </a:ext>
             </a:extLst>
           </p:cNvPr>
@@ -2338,8 +2465,8 @@
         </p:nvSpPr>
         <p:spPr>
           <a:xfrm xmlns:a="http://schemas.openxmlformats.org/drawingml/2006/main">
-            <a:off x="685800" y="6343650"/>
-            <a:ext cx="9906000" cy="266700"/>
+            <a:off x="685800" y="6381750"/>
+            <a:ext cx="7620000" cy="247650"/>
           </a:xfrm>
           <a:prstGeom xmlns:a="http://schemas.openxmlformats.org/drawingml/2006/main" prst="rect">
             <a:avLst/>
@@ -2356,7 +2483,7 @@
           <a:lstStyle xmlns:a="http://schemas.openxmlformats.org/drawingml/2006/main"/>
           <a:p xmlns:a="http://schemas.openxmlformats.org/drawingml/2006/main">
             <a:pPr>
-              <a:defRPr sz="1275" b="0">
+              <a:defRPr sz="1200" b="0">
                 <a:solidFill>
                   <a:srgbClr val="5A687C"/>
                 </a:solidFill>
@@ -2366,7 +2493,7 @@
               </a:defRPr>
             </a:pPr>
             <a:r>
-              <a:rPr sz="1275" b="0">
+              <a:rPr sz="1200" b="0">
                 <a:solidFill>
                   <a:srgbClr val="5A687C"/>
                 </a:solidFill>
@@ -2374,7 +2501,7 @@
                 <a:ea typeface="Noto Sans"/>
                 <a:cs typeface="Noto Sans"/>
               </a:rPr>
-              <a:t>Looplight  /  02</a:t>
+              <a:t>Looplight / 02</a:t>
             </a:r>
           </a:p>
         </p:txBody>
@@ -2382,7 +2509,7 @@
     </p:spTree>
     <p:extLst>
       <p:ext uri="{BB962C8B-B14F-4D97-AF65-F5344CB8AC3E}">
-        <p14:creationId xmlns:p14="http://schemas.microsoft.com/office/powerpoint/2010/main" val="121121548"/>
+        <p14:creationId xmlns:p14="http://schemas.microsoft.com/office/powerpoint/2010/main" val="1297317877"/>
       </p:ext>
     </p:extLst>
   </p:cSld>
@@ -2410,10 +2537,10 @@
       </p:grpSpPr>
       <p:sp>
         <p:nvSpPr>
-          <p:cNvPr id="8" name="text-13">
+          <p:cNvPr id="8" name="text-14">
             <a:extLst>
               <a:ext uri="{FF2B5EF4-FFF2-40B4-BE49-F238E27FC236}">
-                <ns2:creationId id="{25399E84-57C7-4C59-B8E6-93C424517E02}"/>
+                <ns2:creationId id="{892C444C-7505-4B45-9E34-615EDE39676E}"/>
               </a:ext>
             </a:extLst>
           </p:cNvPr>
@@ -2465,37 +2592,172 @@
           </a:p>
         </p:txBody>
       </p:sp>
+      <p:sp>
+        <p:nvSpPr>
+          <p:cNvPr id="2" name="text-15">
+            <a:extLst>
+              <a:ext uri="{FF2B5EF4-FFF2-40B4-BE49-F238E27FC236}">
+                <ns2:creationId id="{379A62B8-52E7-4BD2-A81D-FB2F012586B1}"/>
+              </a:ext>
+            </a:extLst>
+          </p:cNvPr>
+          <p:cNvSpPr>
+            <a:spLocks noGrp="1"/>
+          </p:cNvSpPr>
+          <p:nvPr/>
+        </p:nvSpPr>
+        <p:spPr>
+          <a:xfrm>
+            <a:off x="685800" y="1571625"/>
+            <a:ext cx="7810500" cy="400050"/>
+          </a:xfrm>
+          <a:prstGeom prst="rect">
+            <a:avLst/>
+          </a:prstGeom>
+          <a:noFill/>
+          <a:ln w="0">
+            <a:noFill/>
+          </a:ln>
+        </p:spPr>
+        <p:txBody>
+          <a:bodyPr wrap="square" lIns="0" tIns="0" rIns="0" bIns="0" anchor="t">
+            <a:noAutofit/>
+          </a:bodyPr>
+          <a:lstStyle/>
+          <a:p>
+            <a:pPr>
+              <a:defRPr sz="1800" b="1">
+                <a:solidFill>
+                  <a:srgbClr val="102238"/>
+                </a:solidFill>
+                <a:latin typeface="Noto Sans"/>
+                <a:ea typeface="Noto Sans"/>
+                <a:cs typeface="Noto Sans"/>
+              </a:defRPr>
+            </a:pPr>
+            <a:r>
+              <a:rPr sz="1800" b="1">
+                <a:solidFill>
+                  <a:srgbClr val="102238"/>
+                </a:solidFill>
+                <a:latin typeface="Noto Sans"/>
+                <a:ea typeface="Noto Sans"/>
+                <a:cs typeface="Noto Sans"/>
+              </a:rPr>
+              <a:t>Inspect the original words.</a:t>
+            </a:r>
+          </a:p>
+        </p:txBody>
+      </p:sp>
+      <p:sp>
+        <p:nvSpPr>
+          <p:cNvPr id="3" name="text-16">
+            <a:extLst>
+              <a:ext uri="{FF2B5EF4-FFF2-40B4-BE49-F238E27FC236}">
+                <ns2:creationId id="{8F6B97AB-A1DD-4D1B-AAA3-D6930169E501}"/>
+              </a:ext>
+            </a:extLst>
+          </p:cNvPr>
+          <p:cNvSpPr>
+            <a:spLocks noGrp="1"/>
+          </p:cNvSpPr>
+          <p:nvPr/>
+        </p:nvSpPr>
+        <p:spPr>
+          <a:xfrm>
+            <a:off x="9258300" y="1571625"/>
+            <a:ext cx="2571750" cy="590550"/>
+          </a:xfrm>
+          <a:prstGeom prst="rect">
+            <a:avLst/>
+          </a:prstGeom>
+          <a:noFill/>
+          <a:ln w="0">
+            <a:noFill/>
+          </a:ln>
+        </p:spPr>
+        <p:txBody>
+          <a:bodyPr wrap="square" lIns="0" tIns="0" rIns="0" bIns="0" anchor="t">
+            <a:noAutofit/>
+          </a:bodyPr>
+          <a:lstStyle/>
+          <a:p>
+            <a:pPr>
+              <a:defRPr sz="1650" b="1">
+                <a:solidFill>
+                  <a:srgbClr val="102238"/>
+                </a:solidFill>
+                <a:latin typeface="Noto Sans"/>
+                <a:ea typeface="Noto Sans"/>
+                <a:cs typeface="Noto Sans"/>
+              </a:defRPr>
+            </a:pPr>
+            <a:r>
+              <a:rPr sz="1650" b="1">
+                <a:solidFill>
+                  <a:srgbClr val="102238"/>
+                </a:solidFill>
+                <a:latin typeface="Noto Sans"/>
+                <a:ea typeface="Noto Sans"/>
+                <a:cs typeface="Noto Sans"/>
+              </a:rPr>
+              <a:t>On a smaller screen.</a:t>
+            </a:r>
+          </a:p>
+        </p:txBody>
+      </p:sp>
       <p:pic>
         <p:nvPicPr>
-          <p:cNvPr id="9" name=""/>
+          <p:cNvPr id="11" name=""/>
           <p:cNvPicPr>
             <a:picLocks noChangeAspect="1"/>
           </p:cNvPicPr>
           <p:nvPr/>
         </p:nvPicPr>
         <p:blipFill>
-          <a:blip r:embed="Re7e76ced89754214"/>
-          <a:srcRect l="0" t="0" r="50000" b="56000"/>
-          <a:stretch>
-            <a:fillRect l="0" t="0" r="0" b="0"/>
-          </a:stretch>
+          <a:blip r:embed="R0421df023d9c4906"/>
+          <a:srcRect l="18056" t="45000" r="1389" b="0"/>
+          <a:stretch/>
         </p:blipFill>
         <p:spPr>
           <a:xfrm>
-            <a:off x="685800" y="1581150"/>
-            <a:ext cx="5962650" cy="4762500"/>
+            <a:off x="768927" y="2095500"/>
+            <a:ext cx="7834745" cy="3714750"/>
           </a:xfrm>
           <a:prstGeom prst="rect">
             <a:avLst/>
           </a:prstGeom>
         </p:spPr>
       </p:pic>
-      <p:sp>
-        <p:nvSpPr>
-          <p:cNvPr id="3" name="text-14">
+      <p:pic>
+        <p:nvPicPr>
+          <p:cNvPr id="12" name=""/>
+          <p:cNvPicPr>
+            <a:picLocks noChangeAspect="1"/>
+          </p:cNvPicPr>
+          <p:nvPr/>
+        </p:nvPicPr>
+        <p:blipFill>
+          <a:blip r:embed="Rb8fa6a03084549ba"/>
+          <a:srcRect l="0" t="0" r="0" b="0"/>
+          <a:stretch/>
+        </p:blipFill>
+        <p:spPr>
+          <a:xfrm>
+            <a:off x="9541556" y="2047875"/>
+            <a:ext cx="1738538" cy="3762375"/>
+          </a:xfrm>
+          <a:prstGeom prst="rect">
+            <a:avLst/>
+          </a:prstGeom>
+        </p:spPr>
+      </p:pic>
+      <p:sp>
+        <p:nvSpPr>
+          <p:cNvPr id="6" name="text-17">
             <a:extLst>
               <a:ext uri="{FF2B5EF4-FFF2-40B4-BE49-F238E27FC236}">
-                <ns2:creationId id="{904EA342-B770-4475-8CF7-49CB2B883867}"/>
+                <ns2:creationId id="{247217E4-C901-47AB-ADBF-09ED41277A1D}"/>
               </a:ext>
             </a:extLst>
           </p:cNvPr>
@@ -2506,8 +2768,8 @@
         </p:nvSpPr>
         <p:spPr>
           <a:xfrm>
-            <a:off x="7286625" y="1981200"/>
-            <a:ext cx="4191000" cy="809625"/>
+            <a:off x="685800" y="5962650"/>
+            <a:ext cx="10668000" cy="352425"/>
           </a:xfrm>
           <a:prstGeom prst="rect">
             <a:avLst/>
@@ -2524,7 +2786,7 @@
           <a:lstStyle/>
           <a:p>
             <a:pPr>
-              <a:defRPr sz="2175" b="1">
+              <a:defRPr sz="1875" b="1">
                 <a:solidFill>
                   <a:srgbClr val="102238"/>
                 </a:solidFill>
@@ -2534,7 +2796,7 @@
               </a:defRPr>
             </a:pPr>
             <a:r>
-              <a:rPr sz="2175" b="1">
+              <a:rPr sz="1875" b="1">
                 <a:solidFill>
                   <a:srgbClr val="102238"/>
                 </a:solidFill>
@@ -2542,17 +2804,17 @@
                 <a:ea typeface="Noto Sans"/>
                 <a:cs typeface="Noto Sans"/>
               </a:rPr>
-              <a:t>Each task keeps its source</a:t>
-            </a:r>
-          </a:p>
-        </p:txBody>
-      </p:sp>
-      <p:sp>
-        <p:nvSpPr>
-          <p:cNvPr id="4" name="text-15">
+              <a:t>Review suggestions. Recover omissions. Name the tracker.</a:t>
+            </a:r>
+          </a:p>
+        </p:txBody>
+      </p:sp>
+      <p:sp>
+        <p:nvSpPr>
+          <p:cNvPr id="7" name="text-18">
             <a:extLst>
               <a:ext uri="{FF2B5EF4-FFF2-40B4-BE49-F238E27FC236}">
-                <ns2:creationId id="{F179CBB7-BE3B-4308-A6BE-D09A02FE5F16}"/>
+                <ns2:creationId id="{E03E7337-45A1-4B48-9793-6904CBF6AFDF}"/>
               </a:ext>
             </a:extLst>
           </p:cNvPr>
@@ -2563,8 +2825,8 @@
         </p:nvSpPr>
         <p:spPr>
           <a:xfrm>
-            <a:off x="7286625" y="2914650"/>
-            <a:ext cx="4191000" cy="1009650"/>
+            <a:off x="685800" y="6381750"/>
+            <a:ext cx="7620000" cy="247650"/>
           </a:xfrm>
           <a:prstGeom prst="rect">
             <a:avLst/>
@@ -2581,7 +2843,7 @@
           <a:lstStyle/>
           <a:p>
             <a:pPr>
-              <a:defRPr sz="1875" b="0">
+              <a:defRPr sz="1200" b="0">
                 <a:solidFill>
                   <a:srgbClr val="5A687C"/>
                 </a:solidFill>
@@ -2591,7 +2853,7 @@
               </a:defRPr>
             </a:pPr>
             <a:r>
-              <a:rPr sz="1875" b="0">
+              <a:rPr sz="1200" b="0">
                 <a:solidFill>
                   <a:srgbClr val="5A687C"/>
                 </a:solidFill>
@@ -2599,178 +2861,7 @@
                 <a:ea typeface="Noto Sans"/>
                 <a:cs typeface="Noto Sans"/>
               </a:rPr>
-              <a:t>Open the supporting sentence and review the original wording.</a:t>
-            </a:r>
-          </a:p>
-        </p:txBody>
-      </p:sp>
-      <p:sp>
-        <p:nvSpPr>
-          <p:cNvPr id="5" name="text-16">
-            <a:extLst>
-              <a:ext uri="{FF2B5EF4-FFF2-40B4-BE49-F238E27FC236}">
-                <ns2:creationId id="{F09D14E0-C4FC-4415-89AA-85FAF5B06456}"/>
-              </a:ext>
-            </a:extLst>
-          </p:cNvPr>
-          <p:cNvSpPr>
-            <a:spLocks noGrp="1"/>
-          </p:cNvSpPr>
-          <p:nvPr/>
-        </p:nvSpPr>
-        <p:spPr>
-          <a:xfrm>
-            <a:off x="7286625" y="4286250"/>
-            <a:ext cx="4191000" cy="809625"/>
-          </a:xfrm>
-          <a:prstGeom prst="rect">
-            <a:avLst/>
-          </a:prstGeom>
-          <a:noFill/>
-          <a:ln w="0">
-            <a:noFill/>
-          </a:ln>
-        </p:spPr>
-        <p:txBody>
-          <a:bodyPr wrap="square" lIns="0" tIns="0" rIns="0" bIns="0" anchor="t">
-            <a:noAutofit/>
-          </a:bodyPr>
-          <a:lstStyle/>
-          <a:p>
-            <a:pPr>
-              <a:defRPr sz="2175" b="1">
-                <a:solidFill>
-                  <a:srgbClr val="102238"/>
-                </a:solidFill>
-                <a:latin typeface="Noto Sans"/>
-                <a:ea typeface="Noto Sans"/>
-                <a:cs typeface="Noto Sans"/>
-              </a:defRPr>
-            </a:pPr>
-            <a:r>
-              <a:rPr sz="2175" b="1">
-                <a:solidFill>
-                  <a:srgbClr val="102238"/>
-                </a:solidFill>
-                <a:latin typeface="Noto Sans"/>
-                <a:ea typeface="Noto Sans"/>
-                <a:cs typeface="Noto Sans"/>
-              </a:rPr>
-              <a:t>A person tracks the next step</a:t>
-            </a:r>
-          </a:p>
-        </p:txBody>
-      </p:sp>
-      <p:sp>
-        <p:nvSpPr>
-          <p:cNvPr id="6" name="text-17">
-            <a:extLst>
-              <a:ext uri="{FF2B5EF4-FFF2-40B4-BE49-F238E27FC236}">
-                <ns2:creationId id="{65BED9EC-B654-4579-B616-D07C9839EC1F}"/>
-              </a:ext>
-            </a:extLst>
-          </p:cNvPr>
-          <p:cNvSpPr>
-            <a:spLocks noGrp="1"/>
-          </p:cNvSpPr>
-          <p:nvPr/>
-        </p:nvSpPr>
-        <p:spPr>
-          <a:xfrm>
-            <a:off x="7286625" y="5219700"/>
-            <a:ext cx="4191000" cy="762000"/>
-          </a:xfrm>
-          <a:prstGeom prst="rect">
-            <a:avLst/>
-          </a:prstGeom>
-          <a:noFill/>
-          <a:ln w="0">
-            <a:noFill/>
-          </a:ln>
-        </p:spPr>
-        <p:txBody>
-          <a:bodyPr wrap="square" lIns="0" tIns="0" rIns="0" bIns="0" anchor="t">
-            <a:noAutofit/>
-          </a:bodyPr>
-          <a:lstStyle/>
-          <a:p>
-            <a:pPr>
-              <a:defRPr sz="1875" b="0">
-                <a:solidFill>
-                  <a:srgbClr val="5A687C"/>
-                </a:solidFill>
-                <a:latin typeface="Noto Sans"/>
-                <a:ea typeface="Noto Sans"/>
-                <a:cs typeface="Noto Sans"/>
-              </a:defRPr>
-            </a:pPr>
-            <a:r>
-              <a:rPr sz="1875" b="0">
-                <a:solidFill>
-                  <a:srgbClr val="5A687C"/>
-                </a:solidFill>
-                <a:latin typeface="Noto Sans"/>
-                <a:ea typeface="Noto Sans"/>
-                <a:cs typeface="Noto Sans"/>
-              </a:rPr>
-              <a:t>Confirm the details before following through.</a:t>
-            </a:r>
-          </a:p>
-        </p:txBody>
-      </p:sp>
-      <p:sp>
-        <p:nvSpPr>
-          <p:cNvPr id="7" name="text-18">
-            <a:extLst>
-              <a:ext uri="{FF2B5EF4-FFF2-40B4-BE49-F238E27FC236}">
-                <ns2:creationId id="{12AA87A8-E54E-4350-93AB-767971274DBA}"/>
-              </a:ext>
-            </a:extLst>
-          </p:cNvPr>
-          <p:cNvSpPr>
-            <a:spLocks noGrp="1"/>
-          </p:cNvSpPr>
-          <p:nvPr/>
-        </p:nvSpPr>
-        <p:spPr>
-          <a:xfrm>
-            <a:off x="7286625" y="6096000"/>
-            <a:ext cx="4191000" cy="285750"/>
-          </a:xfrm>
-          <a:prstGeom prst="rect">
-            <a:avLst/>
-          </a:prstGeom>
-          <a:noFill/>
-          <a:ln w="0">
-            <a:noFill/>
-          </a:ln>
-        </p:spPr>
-        <p:txBody>
-          <a:bodyPr wrap="square" lIns="0" tIns="0" rIns="0" bIns="0" anchor="t">
-            <a:noAutofit/>
-          </a:bodyPr>
-          <a:lstStyle/>
-          <a:p>
-            <a:pPr>
-              <a:defRPr sz="1350" b="0">
-                <a:solidFill>
-                  <a:srgbClr val="5A687C"/>
-                </a:solidFill>
-                <a:latin typeface="Noto Sans"/>
-                <a:ea typeface="Noto Sans"/>
-                <a:cs typeface="Noto Sans"/>
-              </a:defRPr>
-            </a:pPr>
-            <a:r>
-              <a:rPr sz="1350" b="0">
-                <a:solidFill>
-                  <a:srgbClr val="5A687C"/>
-                </a:solidFill>
-                <a:latin typeface="Noto Sans"/>
-                <a:ea typeface="Noto Sans"/>
-                <a:cs typeface="Noto Sans"/>
-              </a:rPr>
-              <a:t>Actual app. Fictional data.</a:t>
+              <a:t>Looplight / 03</a:t>
             </a:r>
           </a:p>
         </p:txBody>
@@ -2778,7 +2869,7 @@
     </p:spTree>
     <p:extLst>
       <p:ext uri="{BB962C8B-B14F-4D97-AF65-F5344CB8AC3E}">
-        <ns4:creationId val="1507477233"/>
+        <ns4:creationId val="1216044390"/>
       </p:ext>
     </p:extLst>
   </p:cSld>
@@ -2786,11 +2877,11 @@
 </file>
 
 <file path=ppt/slides/slide4.xml><?xml version="1.0" encoding="utf-8"?>
-<p:sld xmlns:p="http://schemas.openxmlformats.org/presentationml/2006/main">
+<p:sld xmlns:a="http://schemas.openxmlformats.org/drawingml/2006/main" xmlns:ns2="http://schemas.microsoft.com/office/drawing/2014/main" xmlns:ns4="http://schemas.microsoft.com/office/powerpoint/2010/main" xmlns:p="http://schemas.openxmlformats.org/presentationml/2006/main" xmlns:r="http://schemas.openxmlformats.org/officeDocument/2006/relationships">
   <p:cSld>
     <p:bg>
       <p:bgPr>
-        <a:solidFill xmlns:a="http://schemas.openxmlformats.org/drawingml/2006/main">
+        <a:solidFill>
           <a:srgbClr val="102238"/>
         </a:solidFill>
       </p:bgPr>
@@ -2802,41 +2893,41 @@
         <p:nvPr/>
       </p:nvGrpSpPr>
       <p:grpSpPr>
-        <a:xfrm xmlns:a="http://schemas.openxmlformats.org/drawingml/2006/main"/>
+        <a:xfrm/>
       </p:grpSpPr>
       <p:sp>
         <p:nvSpPr>
-          <p:cNvPr id="10" name="text-19">
-            <a:extLst xmlns:a="http://schemas.openxmlformats.org/drawingml/2006/main">
+          <p:cNvPr id="11" name="text-19">
+            <a:extLst>
               <a:ext uri="{FF2B5EF4-FFF2-40B4-BE49-F238E27FC236}">
-                <a16:creationId xmlns:a16="http://schemas.microsoft.com/office/drawing/2014/main" id="{9E22FBCD-DAC4-4230-A563-EBCF3F3B6E01}"/>
+                <ns2:creationId id="{51B98348-86A4-4A94-8B83-99F3EF99E40B}"/>
               </a:ext>
             </a:extLst>
           </p:cNvPr>
           <p:cNvSpPr>
-            <a:spLocks xmlns:a="http://schemas.openxmlformats.org/drawingml/2006/main" noGrp="1"/>
+            <a:spLocks noGrp="1"/>
           </p:cNvSpPr>
           <p:nvPr/>
         </p:nvSpPr>
         <p:spPr>
-          <a:xfrm xmlns:a="http://schemas.openxmlformats.org/drawingml/2006/main">
+          <a:xfrm>
             <a:off x="685800" y="571500"/>
             <a:ext cx="10820400" cy="1104900"/>
           </a:xfrm>
-          <a:prstGeom xmlns:a="http://schemas.openxmlformats.org/drawingml/2006/main" prst="rect">
-            <a:avLst/>
-          </a:prstGeom>
-          <a:noFill xmlns:a="http://schemas.openxmlformats.org/drawingml/2006/main"/>
-          <a:ln xmlns:a="http://schemas.openxmlformats.org/drawingml/2006/main" w="0">
+          <a:prstGeom prst="rect">
+            <a:avLst/>
+          </a:prstGeom>
+          <a:noFill/>
+          <a:ln w="0">
             <a:noFill/>
           </a:ln>
         </p:spPr>
         <p:txBody>
-          <a:bodyPr xmlns:a="http://schemas.openxmlformats.org/drawingml/2006/main" wrap="square" lIns="0" tIns="0" rIns="0" bIns="0" anchor="t">
+          <a:bodyPr wrap="square" lIns="0" tIns="0" rIns="0" bIns="0" anchor="t">
             <a:noAutofit/>
           </a:bodyPr>
-          <a:lstStyle xmlns:a="http://schemas.openxmlformats.org/drawingml/2006/main"/>
-          <a:p xmlns:a="http://schemas.openxmlformats.org/drawingml/2006/main">
+          <a:lstStyle/>
+          <a:p>
             <a:pPr>
               <a:defRPr sz="3675" b="1">
                 <a:solidFill>
@@ -2859,7 +2950,7 @@
               <a:t>A result can arrive</a:t>
             </a:r>
           </a:p>
-          <a:p xmlns:a="http://schemas.openxmlformats.org/drawingml/2006/main">
+          <a:p>
             <a:pPr>
               <a:defRPr sz="3675" b="1">
                 <a:solidFill>
@@ -2887,38 +2978,38 @@
       <p:sp>
         <p:nvSpPr>
           <p:cNvPr id="2" name="text-20">
-            <a:extLst xmlns:a="http://schemas.openxmlformats.org/drawingml/2006/main">
+            <a:extLst>
               <a:ext uri="{FF2B5EF4-FFF2-40B4-BE49-F238E27FC236}">
-                <a16:creationId xmlns:a16="http://schemas.microsoft.com/office/drawing/2014/main" id="{54F2E2F1-F57F-4F30-9DA6-14F0EF417F0E}"/>
+                <ns2:creationId id="{22A52253-C7D0-4528-9D82-7DA8646E6603}"/>
               </a:ext>
             </a:extLst>
           </p:cNvPr>
           <p:cNvSpPr>
-            <a:spLocks xmlns:a="http://schemas.openxmlformats.org/drawingml/2006/main" noGrp="1"/>
+            <a:spLocks noGrp="1"/>
           </p:cNvSpPr>
           <p:nvPr/>
         </p:nvSpPr>
         <p:spPr>
-          <a:xfrm xmlns:a="http://schemas.openxmlformats.org/drawingml/2006/main">
-            <a:off x="685800" y="2228850"/>
-            <a:ext cx="10477500" cy="323850"/>
+          <a:xfrm>
+            <a:off x="685800" y="2381250"/>
+            <a:ext cx="6543675" cy="323850"/>
           </a:xfrm>
-          <a:prstGeom xmlns:a="http://schemas.openxmlformats.org/drawingml/2006/main" prst="rect">
-            <a:avLst/>
-          </a:prstGeom>
-          <a:noFill xmlns:a="http://schemas.openxmlformats.org/drawingml/2006/main"/>
-          <a:ln xmlns:a="http://schemas.openxmlformats.org/drawingml/2006/main" w="0">
+          <a:prstGeom prst="rect">
+            <a:avLst/>
+          </a:prstGeom>
+          <a:noFill/>
+          <a:ln w="0">
             <a:noFill/>
           </a:ln>
         </p:spPr>
         <p:txBody>
-          <a:bodyPr xmlns:a="http://schemas.openxmlformats.org/drawingml/2006/main" wrap="square" lIns="0" tIns="0" rIns="0" bIns="0" anchor="t">
+          <a:bodyPr wrap="square" lIns="0" tIns="0" rIns="0" bIns="0" anchor="t">
             <a:noAutofit/>
           </a:bodyPr>
-          <a:lstStyle xmlns:a="http://schemas.openxmlformats.org/drawingml/2006/main"/>
-          <a:p xmlns:a="http://schemas.openxmlformats.org/drawingml/2006/main">
-            <a:pPr>
-              <a:defRPr sz="1575" b="1">
+          <a:lstStyle/>
+          <a:p>
+            <a:pPr>
+              <a:defRPr sz="1500" b="1">
                 <a:solidFill>
                   <a:srgbClr val="C7F578"/>
                 </a:solidFill>
@@ -2928,7 +3019,7 @@
               </a:defRPr>
             </a:pPr>
             <a:r>
-              <a:rPr sz="1575" b="1">
+              <a:rPr sz="1500" b="1">
                 <a:solidFill>
                   <a:srgbClr val="C7F578"/>
                 </a:solidFill>
@@ -2936,7 +3027,7 @@
                 <a:ea typeface="Noto Sans"/>
                 <a:cs typeface="Noto Sans"/>
               </a:rPr>
-              <a:t>01   RESULT RECEIVED</a:t>
+              <a:t>01  RESULT RECEIVED</a:t>
             </a:r>
           </a:p>
         </p:txBody>
@@ -2944,38 +3035,38 @@
       <p:sp>
         <p:nvSpPr>
           <p:cNvPr id="3" name="text-21">
-            <a:extLst xmlns:a="http://schemas.openxmlformats.org/drawingml/2006/main">
+            <a:extLst>
               <a:ext uri="{FF2B5EF4-FFF2-40B4-BE49-F238E27FC236}">
-                <a16:creationId xmlns:a16="http://schemas.microsoft.com/office/drawing/2014/main" id="{39066912-FE0F-4484-B06F-ED3A97697E4B}"/>
+                <ns2:creationId id="{626AB89F-B7D7-443F-B7ED-AA2D681ECC28}"/>
               </a:ext>
             </a:extLst>
           </p:cNvPr>
           <p:cNvSpPr>
-            <a:spLocks xmlns:a="http://schemas.openxmlformats.org/drawingml/2006/main" noGrp="1"/>
+            <a:spLocks noGrp="1"/>
           </p:cNvSpPr>
           <p:nvPr/>
         </p:nvSpPr>
         <p:spPr>
-          <a:xfrm xmlns:a="http://schemas.openxmlformats.org/drawingml/2006/main">
-            <a:off x="685800" y="2628900"/>
-            <a:ext cx="10477500" cy="523875"/>
+          <a:xfrm>
+            <a:off x="685800" y="2724150"/>
+            <a:ext cx="6400800" cy="590550"/>
           </a:xfrm>
-          <a:prstGeom xmlns:a="http://schemas.openxmlformats.org/drawingml/2006/main" prst="rect">
-            <a:avLst/>
-          </a:prstGeom>
-          <a:noFill xmlns:a="http://schemas.openxmlformats.org/drawingml/2006/main"/>
-          <a:ln xmlns:a="http://schemas.openxmlformats.org/drawingml/2006/main" w="0">
+          <a:prstGeom prst="rect">
+            <a:avLst/>
+          </a:prstGeom>
+          <a:noFill/>
+          <a:ln w="0">
             <a:noFill/>
           </a:ln>
         </p:spPr>
         <p:txBody>
-          <a:bodyPr xmlns:a="http://schemas.openxmlformats.org/drawingml/2006/main" wrap="square" lIns="0" tIns="0" rIns="0" bIns="0" anchor="t">
+          <a:bodyPr wrap="square" lIns="0" tIns="0" rIns="0" bIns="0" anchor="t">
             <a:noAutofit/>
           </a:bodyPr>
-          <a:lstStyle xmlns:a="http://schemas.openxmlformats.org/drawingml/2006/main"/>
-          <a:p xmlns:a="http://schemas.openxmlformats.org/drawingml/2006/main">
-            <a:pPr>
-              <a:defRPr sz="2550" b="0">
+          <a:lstStyle/>
+          <a:p>
+            <a:pPr>
+              <a:defRPr sz="2100" b="0">
                 <a:solidFill>
                   <a:srgbClr val="FFFFFF"/>
                 </a:solidFill>
@@ -2985,7 +3076,7 @@
               </a:defRPr>
             </a:pPr>
             <a:r>
-              <a:rPr sz="2550" b="0">
+              <a:rPr sz="2100" b="0">
                 <a:solidFill>
                   <a:srgbClr val="FFFFFF"/>
                 </a:solidFill>
@@ -3001,38 +3092,38 @@
       <p:sp>
         <p:nvSpPr>
           <p:cNvPr id="4" name="text-22">
-            <a:extLst xmlns:a="http://schemas.openxmlformats.org/drawingml/2006/main">
+            <a:extLst>
               <a:ext uri="{FF2B5EF4-FFF2-40B4-BE49-F238E27FC236}">
-                <a16:creationId xmlns:a16="http://schemas.microsoft.com/office/drawing/2014/main" id="{EA99C30B-8E72-42BA-B0D5-7896F100CEBB}"/>
+                <ns2:creationId id="{8CF9E450-961D-4D89-A741-21671A609ED0}"/>
               </a:ext>
             </a:extLst>
           </p:cNvPr>
           <p:cNvSpPr>
-            <a:spLocks xmlns:a="http://schemas.openxmlformats.org/drawingml/2006/main" noGrp="1"/>
+            <a:spLocks noGrp="1"/>
           </p:cNvSpPr>
           <p:nvPr/>
         </p:nvSpPr>
         <p:spPr>
-          <a:xfrm xmlns:a="http://schemas.openxmlformats.org/drawingml/2006/main">
-            <a:off x="685800" y="3314700"/>
-            <a:ext cx="10477500" cy="323850"/>
+          <a:xfrm>
+            <a:off x="685800" y="3409950"/>
+            <a:ext cx="6543675" cy="323850"/>
           </a:xfrm>
-          <a:prstGeom xmlns:a="http://schemas.openxmlformats.org/drawingml/2006/main" prst="rect">
-            <a:avLst/>
-          </a:prstGeom>
-          <a:noFill xmlns:a="http://schemas.openxmlformats.org/drawingml/2006/main"/>
-          <a:ln xmlns:a="http://schemas.openxmlformats.org/drawingml/2006/main" w="0">
+          <a:prstGeom prst="rect">
+            <a:avLst/>
+          </a:prstGeom>
+          <a:noFill/>
+          <a:ln w="0">
             <a:noFill/>
           </a:ln>
         </p:spPr>
         <p:txBody>
-          <a:bodyPr xmlns:a="http://schemas.openxmlformats.org/drawingml/2006/main" wrap="square" lIns="0" tIns="0" rIns="0" bIns="0" anchor="t">
+          <a:bodyPr wrap="square" lIns="0" tIns="0" rIns="0" bIns="0" anchor="t">
             <a:noAutofit/>
           </a:bodyPr>
-          <a:lstStyle xmlns:a="http://schemas.openxmlformats.org/drawingml/2006/main"/>
-          <a:p xmlns:a="http://schemas.openxmlformats.org/drawingml/2006/main">
-            <a:pPr>
-              <a:defRPr sz="1575" b="1">
+          <a:lstStyle/>
+          <a:p>
+            <a:pPr>
+              <a:defRPr sz="1500" b="1">
                 <a:solidFill>
                   <a:srgbClr val="C7F578"/>
                 </a:solidFill>
@@ -3042,7 +3133,7 @@
               </a:defRPr>
             </a:pPr>
             <a:r>
-              <a:rPr sz="1575" b="1">
+              <a:rPr sz="1500" b="1">
                 <a:solidFill>
                   <a:srgbClr val="C7F578"/>
                 </a:solidFill>
@@ -3050,7 +3141,7 @@
                 <a:ea typeface="Noto Sans"/>
                 <a:cs typeface="Noto Sans"/>
               </a:rPr>
-              <a:t>02   CLINICIAN REVIEW REPORTED</a:t>
+              <a:t>02  CLINICIAN REVIEW REPORTED</a:t>
             </a:r>
           </a:p>
         </p:txBody>
@@ -3058,38 +3149,38 @@
       <p:sp>
         <p:nvSpPr>
           <p:cNvPr id="5" name="text-23">
-            <a:extLst xmlns:a="http://schemas.openxmlformats.org/drawingml/2006/main">
+            <a:extLst>
               <a:ext uri="{FF2B5EF4-FFF2-40B4-BE49-F238E27FC236}">
-                <a16:creationId xmlns:a16="http://schemas.microsoft.com/office/drawing/2014/main" id="{0DE6E9DD-AA3B-4BCB-86DB-A58E54B313BC}"/>
+                <ns2:creationId id="{FA1E96D4-4FD7-4E0E-A4E4-2B94B428F6AE}"/>
               </a:ext>
             </a:extLst>
           </p:cNvPr>
           <p:cNvSpPr>
-            <a:spLocks xmlns:a="http://schemas.openxmlformats.org/drawingml/2006/main" noGrp="1"/>
+            <a:spLocks noGrp="1"/>
           </p:cNvSpPr>
           <p:nvPr/>
         </p:nvSpPr>
         <p:spPr>
-          <a:xfrm xmlns:a="http://schemas.openxmlformats.org/drawingml/2006/main">
-            <a:off x="685800" y="3714750"/>
-            <a:ext cx="10477500" cy="523875"/>
+          <a:xfrm>
+            <a:off x="685800" y="3752850"/>
+            <a:ext cx="6400800" cy="590550"/>
           </a:xfrm>
-          <a:prstGeom xmlns:a="http://schemas.openxmlformats.org/drawingml/2006/main" prst="rect">
-            <a:avLst/>
-          </a:prstGeom>
-          <a:noFill xmlns:a="http://schemas.openxmlformats.org/drawingml/2006/main"/>
-          <a:ln xmlns:a="http://schemas.openxmlformats.org/drawingml/2006/main" w="0">
+          <a:prstGeom prst="rect">
+            <a:avLst/>
+          </a:prstGeom>
+          <a:noFill/>
+          <a:ln w="0">
             <a:noFill/>
           </a:ln>
         </p:spPr>
         <p:txBody>
-          <a:bodyPr xmlns:a="http://schemas.openxmlformats.org/drawingml/2006/main" wrap="square" lIns="0" tIns="0" rIns="0" bIns="0" anchor="t">
+          <a:bodyPr wrap="square" lIns="0" tIns="0" rIns="0" bIns="0" anchor="t">
             <a:noAutofit/>
           </a:bodyPr>
-          <a:lstStyle xmlns:a="http://schemas.openxmlformats.org/drawingml/2006/main"/>
-          <a:p xmlns:a="http://schemas.openxmlformats.org/drawingml/2006/main">
-            <a:pPr>
-              <a:defRPr sz="2550" b="0">
+          <a:lstStyle/>
+          <a:p>
+            <a:pPr>
+              <a:defRPr sz="2100" b="0">
                 <a:solidFill>
                   <a:srgbClr val="FFFFFF"/>
                 </a:solidFill>
@@ -3099,7 +3190,7 @@
               </a:defRPr>
             </a:pPr>
             <a:r>
-              <a:rPr sz="2550" b="0">
+              <a:rPr sz="2100" b="0">
                 <a:solidFill>
                   <a:srgbClr val="FFFFFF"/>
                 </a:solidFill>
@@ -3115,38 +3206,38 @@
       <p:sp>
         <p:nvSpPr>
           <p:cNvPr id="6" name="text-24">
-            <a:extLst xmlns:a="http://schemas.openxmlformats.org/drawingml/2006/main">
+            <a:extLst>
               <a:ext uri="{FF2B5EF4-FFF2-40B4-BE49-F238E27FC236}">
-                <a16:creationId xmlns:a16="http://schemas.microsoft.com/office/drawing/2014/main" id="{EC6F2B81-1817-447D-B6CF-C2AC9F173210}"/>
+                <ns2:creationId id="{96DC666D-140C-452F-8E57-0437BA57AE3A}"/>
               </a:ext>
             </a:extLst>
           </p:cNvPr>
           <p:cNvSpPr>
-            <a:spLocks xmlns:a="http://schemas.openxmlformats.org/drawingml/2006/main" noGrp="1"/>
+            <a:spLocks noGrp="1"/>
           </p:cNvSpPr>
           <p:nvPr/>
         </p:nvSpPr>
         <p:spPr>
-          <a:xfrm xmlns:a="http://schemas.openxmlformats.org/drawingml/2006/main">
-            <a:off x="685800" y="4400550"/>
-            <a:ext cx="10477500" cy="323850"/>
+          <a:xfrm>
+            <a:off x="685800" y="4438650"/>
+            <a:ext cx="6543675" cy="323850"/>
           </a:xfrm>
-          <a:prstGeom xmlns:a="http://schemas.openxmlformats.org/drawingml/2006/main" prst="rect">
-            <a:avLst/>
-          </a:prstGeom>
-          <a:noFill xmlns:a="http://schemas.openxmlformats.org/drawingml/2006/main"/>
-          <a:ln xmlns:a="http://schemas.openxmlformats.org/drawingml/2006/main" w="0">
+          <a:prstGeom prst="rect">
+            <a:avLst/>
+          </a:prstGeom>
+          <a:noFill/>
+          <a:ln w="0">
             <a:noFill/>
           </a:ln>
         </p:spPr>
         <p:txBody>
-          <a:bodyPr xmlns:a="http://schemas.openxmlformats.org/drawingml/2006/main" wrap="square" lIns="0" tIns="0" rIns="0" bIns="0" anchor="t">
+          <a:bodyPr wrap="square" lIns="0" tIns="0" rIns="0" bIns="0" anchor="t">
             <a:noAutofit/>
           </a:bodyPr>
-          <a:lstStyle xmlns:a="http://schemas.openxmlformats.org/drawingml/2006/main"/>
-          <a:p xmlns:a="http://schemas.openxmlformats.org/drawingml/2006/main">
-            <a:pPr>
-              <a:defRPr sz="1575" b="1">
+          <a:lstStyle/>
+          <a:p>
+            <a:pPr>
+              <a:defRPr sz="1500" b="1">
                 <a:solidFill>
                   <a:srgbClr val="C7F578"/>
                 </a:solidFill>
@@ -3156,7 +3247,7 @@
               </a:defRPr>
             </a:pPr>
             <a:r>
-              <a:rPr sz="1575" b="1">
+              <a:rPr sz="1500" b="1">
                 <a:solidFill>
                   <a:srgbClr val="C7F578"/>
                 </a:solidFill>
@@ -3164,7 +3255,7 @@
                 <a:ea typeface="Noto Sans"/>
                 <a:cs typeface="Noto Sans"/>
               </a:rPr>
-              <a:t>03   OUTCOME RECORDED</a:t>
+              <a:t>03  OUTCOME RECORDED</a:t>
             </a:r>
           </a:p>
         </p:txBody>
@@ -3172,38 +3263,38 @@
       <p:sp>
         <p:nvSpPr>
           <p:cNvPr id="7" name="text-25">
-            <a:extLst xmlns:a="http://schemas.openxmlformats.org/drawingml/2006/main">
+            <a:extLst>
               <a:ext uri="{FF2B5EF4-FFF2-40B4-BE49-F238E27FC236}">
-                <a16:creationId xmlns:a16="http://schemas.microsoft.com/office/drawing/2014/main" id="{0F82D784-FFB0-4444-A006-564E53B56BD9}"/>
+                <ns2:creationId id="{A3BEA6E8-5B22-42F1-88D8-434D84894A5C}"/>
               </a:ext>
             </a:extLst>
           </p:cNvPr>
           <p:cNvSpPr>
-            <a:spLocks xmlns:a="http://schemas.openxmlformats.org/drawingml/2006/main" noGrp="1"/>
+            <a:spLocks noGrp="1"/>
           </p:cNvSpPr>
           <p:nvPr/>
         </p:nvSpPr>
         <p:spPr>
-          <a:xfrm xmlns:a="http://schemas.openxmlformats.org/drawingml/2006/main">
-            <a:off x="685800" y="4800600"/>
-            <a:ext cx="10477500" cy="523875"/>
+          <a:xfrm>
+            <a:off x="685800" y="4781550"/>
+            <a:ext cx="6400800" cy="590550"/>
           </a:xfrm>
-          <a:prstGeom xmlns:a="http://schemas.openxmlformats.org/drawingml/2006/main" prst="rect">
-            <a:avLst/>
-          </a:prstGeom>
-          <a:noFill xmlns:a="http://schemas.openxmlformats.org/drawingml/2006/main"/>
-          <a:ln xmlns:a="http://schemas.openxmlformats.org/drawingml/2006/main" w="0">
+          <a:prstGeom prst="rect">
+            <a:avLst/>
+          </a:prstGeom>
+          <a:noFill/>
+          <a:ln w="0">
             <a:noFill/>
           </a:ln>
         </p:spPr>
         <p:txBody>
-          <a:bodyPr xmlns:a="http://schemas.openxmlformats.org/drawingml/2006/main" wrap="square" lIns="0" tIns="0" rIns="0" bIns="0" anchor="t">
+          <a:bodyPr wrap="square" lIns="0" tIns="0" rIns="0" bIns="0" anchor="t">
             <a:noAutofit/>
           </a:bodyPr>
-          <a:lstStyle xmlns:a="http://schemas.openxmlformats.org/drawingml/2006/main"/>
-          <a:p xmlns:a="http://schemas.openxmlformats.org/drawingml/2006/main">
-            <a:pPr>
-              <a:defRPr sz="2550" b="0">
+          <a:lstStyle/>
+          <a:p>
+            <a:pPr>
+              <a:defRPr sz="2100" b="0">
                 <a:solidFill>
                   <a:srgbClr val="FFFFFF"/>
                 </a:solidFill>
@@ -3213,7 +3304,7 @@
               </a:defRPr>
             </a:pPr>
             <a:r>
-              <a:rPr sz="2550" b="0">
+              <a:rPr sz="2100" b="0">
                 <a:solidFill>
                   <a:srgbClr val="FFFFFF"/>
                 </a:solidFill>
@@ -3221,46 +3312,69 @@
                 <a:ea typeface="Noto Sans"/>
                 <a:cs typeface="Noto Sans"/>
               </a:rPr>
-              <a:t>The ledger retains the reported ending.</a:t>
-            </a:r>
-          </a:p>
-        </p:txBody>
-      </p:sp>
-      <p:sp>
-        <p:nvSpPr>
-          <p:cNvPr id="8" name="text-26">
-            <a:extLst xmlns:a="http://schemas.openxmlformats.org/drawingml/2006/main">
+              <a:t>The history keeps the reported ending.</a:t>
+            </a:r>
+          </a:p>
+        </p:txBody>
+      </p:sp>
+      <p:pic>
+        <p:nvPicPr>
+          <p:cNvPr id="18" name=""/>
+          <p:cNvPicPr>
+            <a:picLocks noChangeAspect="1"/>
+          </p:cNvPicPr>
+          <p:nvPr/>
+        </p:nvPicPr>
+        <p:blipFill>
+          <a:blip r:embed="R27ccfbbf9e9945a0"/>
+          <a:srcRect l="57639" t="13200" r="0" b="29800"/>
+          <a:stretch/>
+        </p:blipFill>
+        <p:spPr>
+          <a:xfrm>
+            <a:off x="7643311" y="2076450"/>
+            <a:ext cx="3791953" cy="3543300"/>
+          </a:xfrm>
+          <a:prstGeom prst="rect">
+            <a:avLst/>
+          </a:prstGeom>
+        </p:spPr>
+      </p:pic>
+      <p:sp>
+        <p:nvSpPr>
+          <p:cNvPr id="9" name="text-26">
+            <a:extLst>
               <a:ext uri="{FF2B5EF4-FFF2-40B4-BE49-F238E27FC236}">
-                <a16:creationId xmlns:a16="http://schemas.microsoft.com/office/drawing/2014/main" id="{6851F416-79E9-460B-8C4A-A6D573BA5E6B}"/>
+                <ns2:creationId id="{F7248B52-41B2-4448-85C1-BA6EF541055F}"/>
               </a:ext>
             </a:extLst>
           </p:cNvPr>
           <p:cNvSpPr>
-            <a:spLocks xmlns:a="http://schemas.openxmlformats.org/drawingml/2006/main" noGrp="1"/>
+            <a:spLocks noGrp="1"/>
           </p:cNvSpPr>
           <p:nvPr/>
         </p:nvSpPr>
         <p:spPr>
-          <a:xfrm xmlns:a="http://schemas.openxmlformats.org/drawingml/2006/main">
-            <a:off x="685800" y="5781675"/>
-            <a:ext cx="10668000" cy="361950"/>
+          <a:xfrm>
+            <a:off x="685800" y="5953125"/>
+            <a:ext cx="10820400" cy="333375"/>
           </a:xfrm>
-          <a:prstGeom xmlns:a="http://schemas.openxmlformats.org/drawingml/2006/main" prst="rect">
-            <a:avLst/>
-          </a:prstGeom>
-          <a:noFill xmlns:a="http://schemas.openxmlformats.org/drawingml/2006/main"/>
-          <a:ln xmlns:a="http://schemas.openxmlformats.org/drawingml/2006/main" w="0">
+          <a:prstGeom prst="rect">
+            <a:avLst/>
+          </a:prstGeom>
+          <a:noFill/>
+          <a:ln w="0">
             <a:noFill/>
           </a:ln>
         </p:spPr>
         <p:txBody>
-          <a:bodyPr xmlns:a="http://schemas.openxmlformats.org/drawingml/2006/main" wrap="square" lIns="0" tIns="0" rIns="0" bIns="0" anchor="t">
+          <a:bodyPr wrap="square" lIns="0" tIns="0" rIns="0" bIns="0" anchor="t">
             <a:noAutofit/>
           </a:bodyPr>
-          <a:lstStyle xmlns:a="http://schemas.openxmlformats.org/drawingml/2006/main"/>
-          <a:p xmlns:a="http://schemas.openxmlformats.org/drawingml/2006/main">
-            <a:pPr>
-              <a:defRPr sz="1575" b="0">
+          <a:lstStyle/>
+          <a:p>
+            <a:pPr>
+              <a:defRPr sz="1650" b="0">
                 <a:solidFill>
                   <a:srgbClr val="DCE4EF"/>
                 </a:solidFill>
@@ -3270,7 +3384,7 @@
               </a:defRPr>
             </a:pPr>
             <a:r>
-              <a:rPr sz="1575" b="0">
+              <a:rPr sz="1650" b="0">
                 <a:solidFill>
                   <a:srgbClr val="DCE4EF"/>
                 </a:solidFill>
@@ -3278,46 +3392,46 @@
                 <a:ea typeface="Noto Sans"/>
                 <a:cs typeface="Noto Sans"/>
               </a:rPr>
-              <a:t>These states record user reports. They do not verify clinical outcomes.</a:t>
-            </a:r>
-          </a:p>
-        </p:txBody>
-      </p:sp>
-      <p:sp>
-        <p:nvSpPr>
-          <p:cNvPr id="9" name="text-27">
-            <a:extLst xmlns:a="http://schemas.openxmlformats.org/drawingml/2006/main">
+              <a:t>User reports. No independent clinical verification.</a:t>
+            </a:r>
+          </a:p>
+        </p:txBody>
+      </p:sp>
+      <p:sp>
+        <p:nvSpPr>
+          <p:cNvPr id="10" name="text-27">
+            <a:extLst>
               <a:ext uri="{FF2B5EF4-FFF2-40B4-BE49-F238E27FC236}">
-                <a16:creationId xmlns:a16="http://schemas.microsoft.com/office/drawing/2014/main" id="{31932E37-0E9D-4FCD-8937-2BE61B7C165A}"/>
+                <ns2:creationId id="{87BAD01D-E671-4B72-A155-FE17EF9E4ADB}"/>
               </a:ext>
             </a:extLst>
           </p:cNvPr>
           <p:cNvSpPr>
-            <a:spLocks xmlns:a="http://schemas.openxmlformats.org/drawingml/2006/main" noGrp="1"/>
+            <a:spLocks noGrp="1"/>
           </p:cNvSpPr>
           <p:nvPr/>
         </p:nvSpPr>
         <p:spPr>
-          <a:xfrm xmlns:a="http://schemas.openxmlformats.org/drawingml/2006/main">
-            <a:off x="685800" y="6343650"/>
-            <a:ext cx="9906000" cy="266700"/>
+          <a:xfrm>
+            <a:off x="685800" y="6381750"/>
+            <a:ext cx="7620000" cy="247650"/>
           </a:xfrm>
-          <a:prstGeom xmlns:a="http://schemas.openxmlformats.org/drawingml/2006/main" prst="rect">
-            <a:avLst/>
-          </a:prstGeom>
-          <a:noFill xmlns:a="http://schemas.openxmlformats.org/drawingml/2006/main"/>
-          <a:ln xmlns:a="http://schemas.openxmlformats.org/drawingml/2006/main" w="0">
+          <a:prstGeom prst="rect">
+            <a:avLst/>
+          </a:prstGeom>
+          <a:noFill/>
+          <a:ln w="0">
             <a:noFill/>
           </a:ln>
         </p:spPr>
         <p:txBody>
-          <a:bodyPr xmlns:a="http://schemas.openxmlformats.org/drawingml/2006/main" wrap="square" lIns="0" tIns="0" rIns="0" bIns="0" anchor="t">
+          <a:bodyPr wrap="square" lIns="0" tIns="0" rIns="0" bIns="0" anchor="t">
             <a:noAutofit/>
           </a:bodyPr>
-          <a:lstStyle xmlns:a="http://schemas.openxmlformats.org/drawingml/2006/main"/>
-          <a:p xmlns:a="http://schemas.openxmlformats.org/drawingml/2006/main">
-            <a:pPr>
-              <a:defRPr sz="1275" b="0">
+          <a:lstStyle/>
+          <a:p>
+            <a:pPr>
+              <a:defRPr sz="1200" b="0">
                 <a:solidFill>
                   <a:srgbClr val="DCE4EF"/>
                 </a:solidFill>
@@ -3327,7 +3441,7 @@
               </a:defRPr>
             </a:pPr>
             <a:r>
-              <a:rPr sz="1275" b="0">
+              <a:rPr sz="1200" b="0">
                 <a:solidFill>
                   <a:srgbClr val="DCE4EF"/>
                 </a:solidFill>
@@ -3335,7 +3449,7 @@
                 <a:ea typeface="Noto Sans"/>
                 <a:cs typeface="Noto Sans"/>
               </a:rPr>
-              <a:t>Looplight  /  04</a:t>
+              <a:t>Looplight / 04</a:t>
             </a:r>
           </a:p>
         </p:txBody>
@@ -3343,7 +3457,7 @@
     </p:spTree>
     <p:extLst>
       <p:ext uri="{BB962C8B-B14F-4D97-AF65-F5344CB8AC3E}">
-        <p14:creationId xmlns:p14="http://schemas.microsoft.com/office/powerpoint/2010/main" val="106401457"/>
+        <ns4:creationId val="1961234146"/>
       </p:ext>
     </p:extLst>
   </p:cSld>
@@ -3371,10 +3485,10 @@
       </p:grpSpPr>
       <p:sp>
         <p:nvSpPr>
-          <p:cNvPr id="11" name="text-28">
+          <p:cNvPr id="10" name="text-28">
             <a:extLst xmlns:a="http://schemas.openxmlformats.org/drawingml/2006/main">
               <a:ext uri="{FF2B5EF4-FFF2-40B4-BE49-F238E27FC236}">
-                <a16:creationId xmlns:a16="http://schemas.microsoft.com/office/drawing/2014/main" id="{9F9C4F52-6680-4185-A2B3-5913F7D40281}"/>
+                <a16:creationId xmlns:a16="http://schemas.microsoft.com/office/drawing/2014/main" id="{3C658B97-08C8-4023-8DB9-8F7DA8325584}"/>
               </a:ext>
             </a:extLst>
           </p:cNvPr>
@@ -3421,7 +3535,7 @@
                 <a:ea typeface="Noto Sans"/>
                 <a:cs typeface="Noto Sans"/>
               </a:rPr>
-              <a:t>Small model, visible limits</a:t>
+              <a:t>Measured on known synthetic fixtures</a:t>
             </a:r>
           </a:p>
         </p:txBody>
@@ -3431,7 +3545,7 @@
           <p:cNvPr id="2" name="text-29">
             <a:extLst xmlns:a="http://schemas.openxmlformats.org/drawingml/2006/main">
               <a:ext uri="{FF2B5EF4-FFF2-40B4-BE49-F238E27FC236}">
-                <a16:creationId xmlns:a16="http://schemas.microsoft.com/office/drawing/2014/main" id="{BBCB68CA-CC4B-4981-89CF-83E8E8E4F385}"/>
+                <a16:creationId xmlns:a16="http://schemas.microsoft.com/office/drawing/2014/main" id="{88D6ED5B-A293-41F0-99EB-8B62F9FE89DD}"/>
               </a:ext>
             </a:extLst>
           </p:cNvPr>
@@ -3442,8 +3556,8 @@
         </p:nvSpPr>
         <p:spPr>
           <a:xfrm xmlns:a="http://schemas.openxmlformats.org/drawingml/2006/main">
-            <a:off x="685800" y="2105025"/>
-            <a:ext cx="3143250" cy="1219200"/>
+            <a:off x="685800" y="2076450"/>
+            <a:ext cx="4905375" cy="1209675"/>
           </a:xfrm>
           <a:prstGeom xmlns:a="http://schemas.openxmlformats.org/drawingml/2006/main" prst="rect">
             <a:avLst/>
@@ -3460,7 +3574,7 @@
           <a:lstStyle xmlns:a="http://schemas.openxmlformats.org/drawingml/2006/main"/>
           <a:p xmlns:a="http://schemas.openxmlformats.org/drawingml/2006/main">
             <a:pPr>
-              <a:defRPr sz="7575" b="1">
+              <a:defRPr sz="7500" b="1">
                 <a:solidFill>
                   <a:srgbClr val="315BDB"/>
                 </a:solidFill>
@@ -3470,7 +3584,7 @@
               </a:defRPr>
             </a:pPr>
             <a:r>
-              <a:rPr sz="7575" b="1">
+              <a:rPr sz="7500" b="1">
                 <a:solidFill>
                   <a:srgbClr val="315BDB"/>
                 </a:solidFill>
@@ -3478,7 +3592,7 @@
                 <a:ea typeface="Noto Sans"/>
                 <a:cs typeface="Noto Sans"/>
               </a:rPr>
-              <a:t>82%</a:t>
+              <a:t>33/34</a:t>
             </a:r>
           </a:p>
         </p:txBody>
@@ -3488,7 +3602,7 @@
           <p:cNvPr id="3" name="text-30">
             <a:extLst xmlns:a="http://schemas.openxmlformats.org/drawingml/2006/main">
               <a:ext uri="{FF2B5EF4-FFF2-40B4-BE49-F238E27FC236}">
-                <a16:creationId xmlns:a16="http://schemas.microsoft.com/office/drawing/2014/main" id="{B8488BE9-F44A-49C8-A1EC-4F4CECF61391}"/>
+                <a16:creationId xmlns:a16="http://schemas.microsoft.com/office/drawing/2014/main" id="{780B58D9-5C3F-4776-8B3F-485BA621E8C9}"/>
               </a:ext>
             </a:extLst>
           </p:cNvPr>
@@ -3499,8 +3613,8 @@
         </p:nvSpPr>
         <p:spPr>
           <a:xfrm xmlns:a="http://schemas.openxmlformats.org/drawingml/2006/main">
-            <a:off x="723900" y="3371850"/>
-            <a:ext cx="2952750" cy="742950"/>
+            <a:off x="723900" y="3400425"/>
+            <a:ext cx="4953000" cy="876300"/>
           </a:xfrm>
           <a:prstGeom xmlns:a="http://schemas.openxmlformats.org/drawingml/2006/main" prst="rect">
             <a:avLst/>
@@ -3535,7 +3649,7 @@
                 <a:ea typeface="Noto Sans"/>
                 <a:cs typeface="Noto Sans"/>
               </a:rPr>
-              <a:t>raw five-category</a:t>
+              <a:t>proposals matched</a:t>
             </a:r>
           </a:p>
           <a:p xmlns:a="http://schemas.openxmlformats.org/drawingml/2006/main">
@@ -3558,7 +3672,7 @@
                 <a:ea typeface="Noto Sans"/>
                 <a:cs typeface="Noto Sans"/>
               </a:rPr>
-              <a:t>accuracy</a:t>
+              <a:t>97.1% precision</a:t>
             </a:r>
           </a:p>
         </p:txBody>
@@ -3568,7 +3682,7 @@
           <p:cNvPr id="4" name="text-31">
             <a:extLst xmlns:a="http://schemas.openxmlformats.org/drawingml/2006/main">
               <a:ext uri="{FF2B5EF4-FFF2-40B4-BE49-F238E27FC236}">
-                <a16:creationId xmlns:a16="http://schemas.microsoft.com/office/drawing/2014/main" id="{55E524C9-57B1-4046-BB2D-2C1C2F0BFF50}"/>
+                <a16:creationId xmlns:a16="http://schemas.microsoft.com/office/drawing/2014/main" id="{B6C25E8E-D715-42EE-80F2-5B06C455A224}"/>
               </a:ext>
             </a:extLst>
           </p:cNvPr>
@@ -3579,8 +3693,8 @@
         </p:nvSpPr>
         <p:spPr>
           <a:xfrm xmlns:a="http://schemas.openxmlformats.org/drawingml/2006/main">
-            <a:off x="4495800" y="2105025"/>
-            <a:ext cx="3238500" cy="1219200"/>
+            <a:off x="6210300" y="2076450"/>
+            <a:ext cx="4905375" cy="1209675"/>
           </a:xfrm>
           <a:prstGeom xmlns:a="http://schemas.openxmlformats.org/drawingml/2006/main" prst="rect">
             <a:avLst/>
@@ -3597,7 +3711,7 @@
           <a:lstStyle xmlns:a="http://schemas.openxmlformats.org/drawingml/2006/main"/>
           <a:p xmlns:a="http://schemas.openxmlformats.org/drawingml/2006/main">
             <a:pPr>
-              <a:defRPr sz="6825" b="1">
+              <a:defRPr sz="7500" b="1">
                 <a:solidFill>
                   <a:srgbClr val="315BDB"/>
                 </a:solidFill>
@@ -3607,7 +3721,7 @@
               </a:defRPr>
             </a:pPr>
             <a:r>
-              <a:rPr sz="6825" b="1">
+              <a:rPr sz="7500" b="1">
                 <a:solidFill>
                   <a:srgbClr val="315BDB"/>
                 </a:solidFill>
@@ -3615,7 +3729,7 @@
                 <a:ea typeface="Noto Sans"/>
                 <a:cs typeface="Noto Sans"/>
               </a:rPr>
-              <a:t>0.816</a:t>
+              <a:t>33/44</a:t>
             </a:r>
           </a:p>
         </p:txBody>
@@ -3625,7 +3739,7 @@
           <p:cNvPr id="5" name="text-32">
             <a:extLst xmlns:a="http://schemas.openxmlformats.org/drawingml/2006/main">
               <a:ext uri="{FF2B5EF4-FFF2-40B4-BE49-F238E27FC236}">
-                <a16:creationId xmlns:a16="http://schemas.microsoft.com/office/drawing/2014/main" id="{E183731C-6F2A-452F-A962-72759C68C3B3}"/>
+                <a16:creationId xmlns:a16="http://schemas.microsoft.com/office/drawing/2014/main" id="{AE611BC8-0F3A-4FE4-A7D4-ECE41110D075}"/>
               </a:ext>
             </a:extLst>
           </p:cNvPr>
@@ -3636,8 +3750,8 @@
         </p:nvSpPr>
         <p:spPr>
           <a:xfrm xmlns:a="http://schemas.openxmlformats.org/drawingml/2006/main">
-            <a:off x="4552950" y="3371850"/>
-            <a:ext cx="2952750" cy="742950"/>
+            <a:off x="6248400" y="3400425"/>
+            <a:ext cx="4953000" cy="876300"/>
           </a:xfrm>
           <a:prstGeom xmlns:a="http://schemas.openxmlformats.org/drawingml/2006/main" prst="rect">
             <a:avLst/>
@@ -3672,7 +3786,30 @@
                 <a:ea typeface="Noto Sans"/>
                 <a:cs typeface="Noto Sans"/>
               </a:rPr>
-              <a:t>macro F1</a:t>
+              <a:t>expected actions found</a:t>
+            </a:r>
+          </a:p>
+          <a:p xmlns:a="http://schemas.openxmlformats.org/drawingml/2006/main">
+            <a:pPr>
+              <a:defRPr sz="2175" b="1">
+                <a:solidFill>
+                  <a:srgbClr val="102238"/>
+                </a:solidFill>
+                <a:latin typeface="Noto Sans"/>
+                <a:ea typeface="Noto Sans"/>
+                <a:cs typeface="Noto Sans"/>
+              </a:defRPr>
+            </a:pPr>
+            <a:r>
+              <a:rPr sz="2175" b="1">
+                <a:solidFill>
+                  <a:srgbClr val="102238"/>
+                </a:solidFill>
+                <a:latin typeface="Noto Sans"/>
+                <a:ea typeface="Noto Sans"/>
+                <a:cs typeface="Noto Sans"/>
+              </a:rPr>
+              <a:t>75% recall</a:t>
             </a:r>
           </a:p>
         </p:txBody>
@@ -3682,7 +3819,7 @@
           <p:cNvPr id="6" name="text-33">
             <a:extLst xmlns:a="http://schemas.openxmlformats.org/drawingml/2006/main">
               <a:ext uri="{FF2B5EF4-FFF2-40B4-BE49-F238E27FC236}">
-                <a16:creationId xmlns:a16="http://schemas.microsoft.com/office/drawing/2014/main" id="{B46438F1-A96F-451A-97FF-89F818E3F69A}"/>
+                <a16:creationId xmlns:a16="http://schemas.microsoft.com/office/drawing/2014/main" id="{1B3B65B5-E0BE-479F-B968-A76BE2579164}"/>
               </a:ext>
             </a:extLst>
           </p:cNvPr>
@@ -3693,8 +3830,8 @@
         </p:nvSpPr>
         <p:spPr>
           <a:xfrm xmlns:a="http://schemas.openxmlformats.org/drawingml/2006/main">
-            <a:off x="8315325" y="2105025"/>
-            <a:ext cx="3190875" cy="1219200"/>
+            <a:off x="685800" y="4581525"/>
+            <a:ext cx="10744200" cy="428625"/>
           </a:xfrm>
           <a:prstGeom xmlns:a="http://schemas.openxmlformats.org/drawingml/2006/main" prst="rect">
             <a:avLst/>
@@ -3711,25 +3848,25 @@
           <a:lstStyle xmlns:a="http://schemas.openxmlformats.org/drawingml/2006/main"/>
           <a:p xmlns:a="http://schemas.openxmlformats.org/drawingml/2006/main">
             <a:pPr>
-              <a:defRPr sz="6600" b="1">
-                <a:solidFill>
-                  <a:srgbClr val="315BDB"/>
-                </a:solidFill>
-                <a:latin typeface="Noto Sans"/>
-                <a:ea typeface="Noto Sans"/>
-                <a:cs typeface="Noto Sans"/>
-              </a:defRPr>
-            </a:pPr>
-            <a:r>
-              <a:rPr sz="6600" b="1">
-                <a:solidFill>
-                  <a:srgbClr val="315BDB"/>
-                </a:solidFill>
-                <a:latin typeface="Noto Sans"/>
-                <a:ea typeface="Noto Sans"/>
-                <a:cs typeface="Noto Sans"/>
-              </a:rPr>
-              <a:t>44/50</a:t>
+              <a:defRPr sz="1950" b="0">
+                <a:solidFill>
+                  <a:srgbClr val="5A687C"/>
+                </a:solidFill>
+                <a:latin typeface="Noto Sans"/>
+                <a:ea typeface="Noto Sans"/>
+                <a:cs typeface="Noto Sans"/>
+              </a:defRPr>
+            </a:pPr>
+            <a:r>
+              <a:rPr sz="1950" b="0">
+                <a:solidFill>
+                  <a:srgbClr val="5A687C"/>
+                </a:solidFill>
+                <a:latin typeface="Noto Sans"/>
+                <a:ea typeface="Noto Sans"/>
+                <a:cs typeface="Noto Sans"/>
+              </a:rPr>
+              <a:t>Historical evaluation on 20 known synthetic documents.</a:t>
             </a:r>
           </a:p>
         </p:txBody>
@@ -3739,7 +3876,7 @@
           <p:cNvPr id="7" name="text-34">
             <a:extLst xmlns:a="http://schemas.openxmlformats.org/drawingml/2006/main">
               <a:ext uri="{FF2B5EF4-FFF2-40B4-BE49-F238E27FC236}">
-                <a16:creationId xmlns:a16="http://schemas.microsoft.com/office/drawing/2014/main" id="{7A2C4D92-1CF8-41C2-BBE3-FAEE95CD2843}"/>
+                <a16:creationId xmlns:a16="http://schemas.microsoft.com/office/drawing/2014/main" id="{A54449F0-967A-4EE2-BACD-CEF3F8BC1596}"/>
               </a:ext>
             </a:extLst>
           </p:cNvPr>
@@ -3750,8 +3887,8 @@
         </p:nvSpPr>
         <p:spPr>
           <a:xfrm xmlns:a="http://schemas.openxmlformats.org/drawingml/2006/main">
-            <a:off x="8372475" y="3371850"/>
-            <a:ext cx="3095625" cy="857250"/>
+            <a:off x="685800" y="5172075"/>
+            <a:ext cx="10744200" cy="523875"/>
           </a:xfrm>
           <a:prstGeom xmlns:a="http://schemas.openxmlformats.org/drawingml/2006/main" prst="rect">
             <a:avLst/>
@@ -3768,7 +3905,7 @@
           <a:lstStyle xmlns:a="http://schemas.openxmlformats.org/drawingml/2006/main"/>
           <a:p xmlns:a="http://schemas.openxmlformats.org/drawingml/2006/main">
             <a:pPr>
-              <a:defRPr sz="2025" b="1">
+              <a:defRPr sz="2175" b="1">
                 <a:solidFill>
                   <a:srgbClr val="102238"/>
                 </a:solidFill>
@@ -3778,7 +3915,7 @@
               </a:defRPr>
             </a:pPr>
             <a:r>
-              <a:rPr sz="2025" b="1">
+              <a:rPr sz="2175" b="1">
                 <a:solidFill>
                   <a:srgbClr val="102238"/>
                 </a:solidFill>
@@ -3786,30 +3923,7 @@
                 <a:ea typeface="Noto Sans"/>
                 <a:cs typeface="Noto Sans"/>
               </a:rPr>
-              <a:t>abstained at the</a:t>
-            </a:r>
-          </a:p>
-          <a:p xmlns:a="http://schemas.openxmlformats.org/drawingml/2006/main">
-            <a:pPr>
-              <a:defRPr sz="2025" b="1">
-                <a:solidFill>
-                  <a:srgbClr val="102238"/>
-                </a:solidFill>
-                <a:latin typeface="Noto Sans"/>
-                <a:ea typeface="Noto Sans"/>
-                <a:cs typeface="Noto Sans"/>
-              </a:defRPr>
-            </a:pPr>
-            <a:r>
-              <a:rPr sz="2025" b="1">
-                <a:solidFill>
-                  <a:srgbClr val="102238"/>
-                </a:solidFill>
-                <a:latin typeface="Noto Sans"/>
-                <a:ea typeface="Noto Sans"/>
-                <a:cs typeface="Noto Sans"/>
-              </a:rPr>
-              <a:t>configured threshold</a:t>
+              <a:t>Reused during fixes. Not held-out or clinical validation.</a:t>
             </a:r>
           </a:p>
         </p:txBody>
@@ -3819,7 +3933,7 @@
           <p:cNvPr id="8" name="text-35">
             <a:extLst xmlns:a="http://schemas.openxmlformats.org/drawingml/2006/main">
               <a:ext uri="{FF2B5EF4-FFF2-40B4-BE49-F238E27FC236}">
-                <a16:creationId xmlns:a16="http://schemas.microsoft.com/office/drawing/2014/main" id="{219161CC-E11D-4ED0-8368-5ADC2272EEE4}"/>
+                <a16:creationId xmlns:a16="http://schemas.microsoft.com/office/drawing/2014/main" id="{96CE92AF-9C33-4338-80E2-4920D085A7D3}"/>
               </a:ext>
             </a:extLst>
           </p:cNvPr>
@@ -3830,8 +3944,8 @@
         </p:nvSpPr>
         <p:spPr>
           <a:xfrm xmlns:a="http://schemas.openxmlformats.org/drawingml/2006/main">
-            <a:off x="685800" y="4724400"/>
-            <a:ext cx="10668000" cy="419100"/>
+            <a:off x="685800" y="5838825"/>
+            <a:ext cx="10744200" cy="342900"/>
           </a:xfrm>
           <a:prstGeom xmlns:a="http://schemas.openxmlformats.org/drawingml/2006/main" prst="rect">
             <a:avLst/>
@@ -3848,7 +3962,7 @@
           <a:lstStyle xmlns:a="http://schemas.openxmlformats.org/drawingml/2006/main"/>
           <a:p xmlns:a="http://schemas.openxmlformats.org/drawingml/2006/main">
             <a:pPr>
-              <a:defRPr sz="1800" b="0">
+              <a:defRPr sz="1725" b="0">
                 <a:solidFill>
                   <a:srgbClr val="5A687C"/>
                 </a:solidFill>
@@ -3858,7 +3972,7 @@
               </a:defRPr>
             </a:pPr>
             <a:r>
-              <a:rPr sz="1800" b="0">
+              <a:rPr sz="1725" b="0">
                 <a:solidFill>
                   <a:srgbClr val="5A687C"/>
                 </a:solidFill>
@@ -3866,7 +3980,7 @@
                 <a:ea typeface="Noto Sans"/>
                 <a:cs typeface="Noto Sans"/>
               </a:rPr>
-              <a:t>225 synthetic training examples. 50 separately authored challenge examples.</a:t>
+              <a:t>The next evaluation needs independently annotated documents.</a:t>
             </a:r>
           </a:p>
         </p:txBody>
@@ -3876,7 +3990,7 @@
           <p:cNvPr id="9" name="text-36">
             <a:extLst xmlns:a="http://schemas.openxmlformats.org/drawingml/2006/main">
               <a:ext uri="{FF2B5EF4-FFF2-40B4-BE49-F238E27FC236}">
-                <a16:creationId xmlns:a16="http://schemas.microsoft.com/office/drawing/2014/main" id="{52F054E1-3289-4258-B908-4192CE18AFBD}"/>
+                <a16:creationId xmlns:a16="http://schemas.microsoft.com/office/drawing/2014/main" id="{1A09DC2F-1E5F-444D-AD6E-4BED6A74EE4E}"/>
               </a:ext>
             </a:extLst>
           </p:cNvPr>
@@ -3887,8 +4001,8 @@
         </p:nvSpPr>
         <p:spPr>
           <a:xfrm xmlns:a="http://schemas.openxmlformats.org/drawingml/2006/main">
-            <a:off x="685800" y="5286375"/>
-            <a:ext cx="10668000" cy="704850"/>
+            <a:off x="685800" y="6381750"/>
+            <a:ext cx="7620000" cy="247650"/>
           </a:xfrm>
           <a:prstGeom xmlns:a="http://schemas.openxmlformats.org/drawingml/2006/main" prst="rect">
             <a:avLst/>
@@ -3905,64 +4019,7 @@
           <a:lstStyle xmlns:a="http://schemas.openxmlformats.org/drawingml/2006/main"/>
           <a:p xmlns:a="http://schemas.openxmlformats.org/drawingml/2006/main">
             <a:pPr>
-              <a:defRPr sz="2100" b="1">
-                <a:solidFill>
-                  <a:srgbClr val="102238"/>
-                </a:solidFill>
-                <a:latin typeface="Noto Sans"/>
-                <a:ea typeface="Noto Sans"/>
-                <a:cs typeface="Noto Sans"/>
-              </a:defRPr>
-            </a:pPr>
-            <a:r>
-              <a:rPr sz="2100" b="1">
-                <a:solidFill>
-                  <a:srgbClr val="102238"/>
-                </a:solidFill>
-                <a:latin typeface="Noto Sans"/>
-                <a:ea typeface="Noto Sans"/>
-                <a:cs typeface="Noto Sans"/>
-              </a:rPr>
-              <a:t>Synthetic classification evidence. Clinical validation remains outstanding.</a:t>
-            </a:r>
-          </a:p>
-        </p:txBody>
-      </p:sp>
-      <p:sp>
-        <p:nvSpPr>
-          <p:cNvPr id="10" name="text-37">
-            <a:extLst xmlns:a="http://schemas.openxmlformats.org/drawingml/2006/main">
-              <a:ext uri="{FF2B5EF4-FFF2-40B4-BE49-F238E27FC236}">
-                <a16:creationId xmlns:a16="http://schemas.microsoft.com/office/drawing/2014/main" id="{AAFE4F28-EB48-46DE-9771-7EDA64197F8E}"/>
-              </a:ext>
-            </a:extLst>
-          </p:cNvPr>
-          <p:cNvSpPr>
-            <a:spLocks xmlns:a="http://schemas.openxmlformats.org/drawingml/2006/main" noGrp="1"/>
-          </p:cNvSpPr>
-          <p:nvPr/>
-        </p:nvSpPr>
-        <p:spPr>
-          <a:xfrm xmlns:a="http://schemas.openxmlformats.org/drawingml/2006/main">
-            <a:off x="685800" y="6343650"/>
-            <a:ext cx="9906000" cy="266700"/>
-          </a:xfrm>
-          <a:prstGeom xmlns:a="http://schemas.openxmlformats.org/drawingml/2006/main" prst="rect">
-            <a:avLst/>
-          </a:prstGeom>
-          <a:noFill xmlns:a="http://schemas.openxmlformats.org/drawingml/2006/main"/>
-          <a:ln xmlns:a="http://schemas.openxmlformats.org/drawingml/2006/main" w="0">
-            <a:noFill/>
-          </a:ln>
-        </p:spPr>
-        <p:txBody>
-          <a:bodyPr xmlns:a="http://schemas.openxmlformats.org/drawingml/2006/main" wrap="square" lIns="0" tIns="0" rIns="0" bIns="0" anchor="t">
-            <a:noAutofit/>
-          </a:bodyPr>
-          <a:lstStyle xmlns:a="http://schemas.openxmlformats.org/drawingml/2006/main"/>
-          <a:p xmlns:a="http://schemas.openxmlformats.org/drawingml/2006/main">
-            <a:pPr>
-              <a:defRPr sz="1275" b="0">
+              <a:defRPr sz="1200" b="0">
                 <a:solidFill>
                   <a:srgbClr val="5A687C"/>
                 </a:solidFill>
@@ -3972,7 +4029,7 @@
               </a:defRPr>
             </a:pPr>
             <a:r>
-              <a:rPr sz="1275" b="0">
+              <a:rPr sz="1200" b="0">
                 <a:solidFill>
                   <a:srgbClr val="5A687C"/>
                 </a:solidFill>
@@ -3980,7 +4037,7 @@
                 <a:ea typeface="Noto Sans"/>
                 <a:cs typeface="Noto Sans"/>
               </a:rPr>
-              <a:t>Looplight  /  05</a:t>
+              <a:t>Looplight / 05</a:t>
             </a:r>
           </a:p>
         </p:txBody>
@@ -3988,7 +4045,7 @@
     </p:spTree>
     <p:extLst>
       <p:ext uri="{BB962C8B-B14F-4D97-AF65-F5344CB8AC3E}">
-        <p14:creationId xmlns:p14="http://schemas.microsoft.com/office/powerpoint/2010/main" val="1279393062"/>
+        <p14:creationId xmlns:p14="http://schemas.microsoft.com/office/powerpoint/2010/main" val="890677522"/>
       </p:ext>
     </p:extLst>
   </p:cSld>
@@ -4016,10 +4073,10 @@
       </p:grpSpPr>
       <p:sp>
         <p:nvSpPr>
-          <p:cNvPr id="9" name="text-38">
+          <p:cNvPr id="9" name="text-37">
             <a:extLst xmlns:a="http://schemas.openxmlformats.org/drawingml/2006/main">
               <a:ext uri="{FF2B5EF4-FFF2-40B4-BE49-F238E27FC236}">
-                <a16:creationId xmlns:a16="http://schemas.microsoft.com/office/drawing/2014/main" id="{94EF23E2-56BA-43A7-98F2-D2A264364085}"/>
+                <a16:creationId xmlns:a16="http://schemas.microsoft.com/office/drawing/2014/main" id="{D0FB35AE-7864-4471-A30F-E22F8875D0DE}"/>
               </a:ext>
             </a:extLst>
           </p:cNvPr>
@@ -4073,10 +4130,10 @@
       </p:sp>
       <p:sp>
         <p:nvSpPr>
-          <p:cNvPr id="2" name="text-39">
+          <p:cNvPr id="2" name="text-38">
             <a:extLst xmlns:a="http://schemas.openxmlformats.org/drawingml/2006/main">
               <a:ext uri="{FF2B5EF4-FFF2-40B4-BE49-F238E27FC236}">
-                <a16:creationId xmlns:a16="http://schemas.microsoft.com/office/drawing/2014/main" id="{F41BB68A-44A8-418C-BF55-71A183565B6D}"/>
+                <a16:creationId xmlns:a16="http://schemas.microsoft.com/office/drawing/2014/main" id="{62C7CBEE-FC23-4482-8744-DBD3EFC163C1}"/>
               </a:ext>
             </a:extLst>
           </p:cNvPr>
@@ -4153,10 +4210,10 @@
       </p:sp>
       <p:sp>
         <p:nvSpPr>
-          <p:cNvPr id="3" name="text-40">
+          <p:cNvPr id="3" name="text-39">
             <a:extLst xmlns:a="http://schemas.openxmlformats.org/drawingml/2006/main">
               <a:ext uri="{FF2B5EF4-FFF2-40B4-BE49-F238E27FC236}">
-                <a16:creationId xmlns:a16="http://schemas.microsoft.com/office/drawing/2014/main" id="{6F12CF43-478B-4AC3-B23E-FF5F329E7E5A}"/>
+                <a16:creationId xmlns:a16="http://schemas.microsoft.com/office/drawing/2014/main" id="{F0322019-1095-4978-84AB-B64D2661DD24}"/>
               </a:ext>
             </a:extLst>
           </p:cNvPr>
@@ -4210,10 +4267,10 @@
       </p:sp>
       <p:sp>
         <p:nvSpPr>
-          <p:cNvPr id="4" name="text-41">
+          <p:cNvPr id="4" name="text-40">
             <a:extLst xmlns:a="http://schemas.openxmlformats.org/drawingml/2006/main">
               <a:ext uri="{FF2B5EF4-FFF2-40B4-BE49-F238E27FC236}">
-                <a16:creationId xmlns:a16="http://schemas.microsoft.com/office/drawing/2014/main" id="{6F9FB169-9740-41F2-A94A-C234D31EEC44}"/>
+                <a16:creationId xmlns:a16="http://schemas.microsoft.com/office/drawing/2014/main" id="{1430B7D6-EC51-4DEA-8F57-E0DE55CF6FA6}"/>
               </a:ext>
             </a:extLst>
           </p:cNvPr>
@@ -4290,10 +4347,10 @@
       </p:sp>
       <p:sp>
         <p:nvSpPr>
-          <p:cNvPr id="5" name="text-42">
+          <p:cNvPr id="5" name="text-41">
             <a:extLst xmlns:a="http://schemas.openxmlformats.org/drawingml/2006/main">
               <a:ext uri="{FF2B5EF4-FFF2-40B4-BE49-F238E27FC236}">
-                <a16:creationId xmlns:a16="http://schemas.microsoft.com/office/drawing/2014/main" id="{D37F921A-CCFB-41C6-AF1E-CD9352EFF454}"/>
+                <a16:creationId xmlns:a16="http://schemas.microsoft.com/office/drawing/2014/main" id="{3D3C1EC3-8F2C-43CD-93BE-B95AE925C460}"/>
               </a:ext>
             </a:extLst>
           </p:cNvPr>
@@ -4347,10 +4404,10 @@
       </p:sp>
       <p:sp>
         <p:nvSpPr>
-          <p:cNvPr id="6" name="text-43">
+          <p:cNvPr id="6" name="text-42">
             <a:extLst xmlns:a="http://schemas.openxmlformats.org/drawingml/2006/main">
               <a:ext uri="{FF2B5EF4-FFF2-40B4-BE49-F238E27FC236}">
-                <a16:creationId xmlns:a16="http://schemas.microsoft.com/office/drawing/2014/main" id="{224564E0-64E4-4149-A3B3-3C6DA78BED81}"/>
+                <a16:creationId xmlns:a16="http://schemas.microsoft.com/office/drawing/2014/main" id="{4BC6A486-7611-4534-B1D6-588FBF184A5F}"/>
               </a:ext>
             </a:extLst>
           </p:cNvPr>
@@ -4420,7 +4477,7 @@
                 <a:ea typeface="Noto Sans"/>
                 <a:cs typeface="Noto Sans"/>
               </a:rPr>
-              <a:t>Five minutes saved × 100 episodes</a:t>
+              <a:t>Five minutes saved x 100 episodes</a:t>
             </a:r>
           </a:p>
           <a:p xmlns:a="http://schemas.openxmlformats.org/drawingml/2006/main">
@@ -4450,10 +4507,10 @@
       </p:sp>
       <p:sp>
         <p:nvSpPr>
-          <p:cNvPr id="7" name="text-44">
+          <p:cNvPr id="7" name="text-43">
             <a:extLst xmlns:a="http://schemas.openxmlformats.org/drawingml/2006/main">
               <a:ext uri="{FF2B5EF4-FFF2-40B4-BE49-F238E27FC236}">
-                <a16:creationId xmlns:a16="http://schemas.microsoft.com/office/drawing/2014/main" id="{36EC6C86-B21C-4522-939B-BD6C4A8BBCC4}"/>
+                <a16:creationId xmlns:a16="http://schemas.microsoft.com/office/drawing/2014/main" id="{25E42133-9EF6-4293-9C9D-D516AA4040B8}"/>
               </a:ext>
             </a:extLst>
           </p:cNvPr>
@@ -4507,10 +4564,10 @@
       </p:sp>
       <p:sp>
         <p:nvSpPr>
-          <p:cNvPr id="8" name="text-45">
+          <p:cNvPr id="8" name="text-44">
             <a:extLst xmlns:a="http://schemas.openxmlformats.org/drawingml/2006/main">
               <a:ext uri="{FF2B5EF4-FFF2-40B4-BE49-F238E27FC236}">
-                <a16:creationId xmlns:a16="http://schemas.microsoft.com/office/drawing/2014/main" id="{76AA6FCE-5FF6-4320-974E-C4E8F5862696}"/>
+                <a16:creationId xmlns:a16="http://schemas.microsoft.com/office/drawing/2014/main" id="{4DB920E0-6766-450F-A816-DDBD99A14D6E}"/>
               </a:ext>
             </a:extLst>
           </p:cNvPr>
@@ -4521,8 +4578,8 @@
         </p:nvSpPr>
         <p:spPr>
           <a:xfrm xmlns:a="http://schemas.openxmlformats.org/drawingml/2006/main">
-            <a:off x="685800" y="6343650"/>
-            <a:ext cx="9906000" cy="266700"/>
+            <a:off x="685800" y="6381750"/>
+            <a:ext cx="7620000" cy="247650"/>
           </a:xfrm>
           <a:prstGeom xmlns:a="http://schemas.openxmlformats.org/drawingml/2006/main" prst="rect">
             <a:avLst/>
@@ -4539,7 +4596,7 @@
           <a:lstStyle xmlns:a="http://schemas.openxmlformats.org/drawingml/2006/main"/>
           <a:p xmlns:a="http://schemas.openxmlformats.org/drawingml/2006/main">
             <a:pPr>
-              <a:defRPr sz="1275" b="0">
+              <a:defRPr sz="1200" b="0">
                 <a:solidFill>
                   <a:srgbClr val="5A687C"/>
                 </a:solidFill>
@@ -4549,7 +4606,7 @@
               </a:defRPr>
             </a:pPr>
             <a:r>
-              <a:rPr sz="1275" b="0">
+              <a:rPr sz="1200" b="0">
                 <a:solidFill>
                   <a:srgbClr val="5A687C"/>
                 </a:solidFill>
@@ -4557,7 +4614,7 @@
                 <a:ea typeface="Noto Sans"/>
                 <a:cs typeface="Noto Sans"/>
               </a:rPr>
-              <a:t>Looplight  /  06</a:t>
+              <a:t>Looplight / 06</a:t>
             </a:r>
           </a:p>
         </p:txBody>
@@ -4565,7 +4622,7 @@
     </p:spTree>
     <p:extLst>
       <p:ext uri="{BB962C8B-B14F-4D97-AF65-F5344CB8AC3E}">
-        <p14:creationId xmlns:p14="http://schemas.microsoft.com/office/powerpoint/2010/main" val="1132469266"/>
+        <p14:creationId xmlns:p14="http://schemas.microsoft.com/office/powerpoint/2010/main" val="2047719799"/>
       </p:ext>
     </p:extLst>
   </p:cSld>
@@ -4593,10 +4650,10 @@
       </p:grpSpPr>
       <p:sp>
         <p:nvSpPr>
-          <p:cNvPr id="6" name="text-46">
+          <p:cNvPr id="9" name="text-45">
             <a:extLst xmlns:a="http://schemas.openxmlformats.org/drawingml/2006/main">
               <a:ext uri="{FF2B5EF4-FFF2-40B4-BE49-F238E27FC236}">
-                <a16:creationId xmlns:a16="http://schemas.microsoft.com/office/drawing/2014/main" id="{D15C9BA3-156E-4F87-BA25-A9E0D0C20E00}"/>
+                <a16:creationId xmlns:a16="http://schemas.microsoft.com/office/drawing/2014/main" id="{202783B6-D3C3-4A93-8E45-53BA1E6C3F5C}"/>
               </a:ext>
             </a:extLst>
           </p:cNvPr>
@@ -4643,17 +4700,17 @@
                 <a:ea typeface="Noto Sans"/>
                 <a:cs typeface="Noto Sans"/>
               </a:rPr>
-              <a:t>The next proof is a supervised pilot</a:t>
-            </a:r>
-          </a:p>
-        </p:txBody>
-      </p:sp>
-      <p:sp>
-        <p:nvSpPr>
-          <p:cNvPr id="2" name="text-47">
+              <a:t>Built to inspect. The next proof is a pilot.</a:t>
+            </a:r>
+          </a:p>
+        </p:txBody>
+      </p:sp>
+      <p:sp>
+        <p:nvSpPr>
+          <p:cNvPr id="2" name="text-46">
             <a:extLst xmlns:a="http://schemas.openxmlformats.org/drawingml/2006/main">
               <a:ext uri="{FF2B5EF4-FFF2-40B4-BE49-F238E27FC236}">
-                <a16:creationId xmlns:a16="http://schemas.microsoft.com/office/drawing/2014/main" id="{F86BB7A8-BCE5-4F6E-8A58-6EC5EC2706FD}"/>
+                <a16:creationId xmlns:a16="http://schemas.microsoft.com/office/drawing/2014/main" id="{13BA903E-93C8-4321-B8A4-5A6D4EF4AA06}"/>
               </a:ext>
             </a:extLst>
           </p:cNvPr>
@@ -4664,8 +4721,8 @@
         </p:nvSpPr>
         <p:spPr>
           <a:xfrm xmlns:a="http://schemas.openxmlformats.org/drawingml/2006/main">
-            <a:off x="685800" y="2171700"/>
-            <a:ext cx="10744200" cy="762000"/>
+            <a:off x="685800" y="2124075"/>
+            <a:ext cx="5143500" cy="723900"/>
           </a:xfrm>
           <a:prstGeom xmlns:a="http://schemas.openxmlformats.org/drawingml/2006/main" prst="rect">
             <a:avLst/>
@@ -4682,35 +4739,35 @@
           <a:lstStyle xmlns:a="http://schemas.openxmlformats.org/drawingml/2006/main"/>
           <a:p xmlns:a="http://schemas.openxmlformats.org/drawingml/2006/main">
             <a:pPr>
-              <a:defRPr sz="3150" b="1">
-                <a:solidFill>
-                  <a:srgbClr val="FFFFFF"/>
-                </a:solidFill>
-                <a:latin typeface="Noto Sans"/>
-                <a:ea typeface="Noto Sans"/>
-                <a:cs typeface="Noto Sans"/>
-              </a:defRPr>
-            </a:pPr>
-            <a:r>
-              <a:rPr sz="3150" b="1">
-                <a:solidFill>
-                  <a:srgbClr val="FFFFFF"/>
-                </a:solidFill>
-                <a:latin typeface="Noto Sans"/>
-                <a:ea typeface="Noto Sans"/>
-                <a:cs typeface="Noto Sans"/>
-              </a:rPr>
-              <a:t>Can staff prepare a reliable plan faster?</a:t>
-            </a:r>
-          </a:p>
-        </p:txBody>
-      </p:sp>
-      <p:sp>
-        <p:nvSpPr>
-          <p:cNvPr id="3" name="text-48">
+              <a:defRPr sz="2325" b="1">
+                <a:solidFill>
+                  <a:srgbClr val="C7F578"/>
+                </a:solidFill>
+                <a:latin typeface="Noto Sans"/>
+                <a:ea typeface="Noto Sans"/>
+                <a:cs typeface="Noto Sans"/>
+              </a:defRPr>
+            </a:pPr>
+            <a:r>
+              <a:rPr sz="2325" b="1">
+                <a:solidFill>
+                  <a:srgbClr val="C7F578"/>
+                </a:solidFill>
+                <a:latin typeface="Noto Sans"/>
+                <a:ea typeface="Noto Sans"/>
+                <a:cs typeface="Noto Sans"/>
+              </a:rPr>
+              <a:t>A complete browser workflow</a:t>
+            </a:r>
+          </a:p>
+        </p:txBody>
+      </p:sp>
+      <p:sp>
+        <p:nvSpPr>
+          <p:cNvPr id="3" name="text-47">
             <a:extLst xmlns:a="http://schemas.openxmlformats.org/drawingml/2006/main">
               <a:ext uri="{FF2B5EF4-FFF2-40B4-BE49-F238E27FC236}">
-                <a16:creationId xmlns:a16="http://schemas.microsoft.com/office/drawing/2014/main" id="{819B0E24-77BE-4B0F-809D-29B17C23C294}"/>
+                <a16:creationId xmlns:a16="http://schemas.microsoft.com/office/drawing/2014/main" id="{D3249DC3-C0F1-46F4-BDE1-0E1964CFCD01}"/>
               </a:ext>
             </a:extLst>
           </p:cNvPr>
@@ -4721,8 +4778,8 @@
         </p:nvSpPr>
         <p:spPr>
           <a:xfrm xmlns:a="http://schemas.openxmlformats.org/drawingml/2006/main">
-            <a:off x="685800" y="3295650"/>
-            <a:ext cx="10620375" cy="1047750"/>
+            <a:off x="685800" y="3019425"/>
+            <a:ext cx="5143500" cy="1657350"/>
           </a:xfrm>
           <a:prstGeom xmlns:a="http://schemas.openxmlformats.org/drawingml/2006/main" prst="rect">
             <a:avLst/>
@@ -4739,7 +4796,7 @@
           <a:lstStyle xmlns:a="http://schemas.openxmlformats.org/drawingml/2006/main"/>
           <a:p xmlns:a="http://schemas.openxmlformats.org/drawingml/2006/main">
             <a:pPr>
-              <a:defRPr sz="2325" b="0">
+              <a:defRPr sz="2025" b="0">
                 <a:solidFill>
                   <a:srgbClr val="FFFFFF"/>
                 </a:solidFill>
@@ -4749,7 +4806,7 @@
               </a:defRPr>
             </a:pPr>
             <a:r>
-              <a:rPr sz="2325" b="0">
+              <a:rPr sz="2025" b="0">
                 <a:solidFill>
                   <a:srgbClr val="FFFFFF"/>
                 </a:solidFill>
@@ -4757,12 +4814,12 @@
                 <a:ea typeface="Noto Sans"/>
                 <a:cs typeface="Noto Sans"/>
               </a:rPr>
-              <a:t>Measure missed actions, corrections, and preparation time.</a:t>
-            </a:r>
-          </a:p>
-          <a:p xmlns:a="http://schemas.openxmlformats.org/drawingml/2006/main">
-            <a:pPr>
-              <a:defRPr sz="2325" b="0">
+              <a:t>Browser: model, rules, and transitions.</a:t>
+            </a:r>
+          </a:p>
+          <a:p xmlns:a="http://schemas.openxmlformats.org/drawingml/2006/main">
+            <a:pPr>
+              <a:defRPr sz="2025" b="0">
                 <a:solidFill>
                   <a:srgbClr val="FFFFFF"/>
                 </a:solidFill>
@@ -4772,7 +4829,7 @@
               </a:defRPr>
             </a:pPr>
             <a:r>
-              <a:rPr sz="2325" b="0">
+              <a:rPr sz="2025" b="0">
                 <a:solidFill>
                   <a:srgbClr val="FFFFFF"/>
                 </a:solidFill>
@@ -4780,17 +4837,63 @@
                 <a:ea typeface="Noto Sans"/>
                 <a:cs typeface="Noto Sans"/>
               </a:rPr>
-              <a:t>Then track follow-up resolution under supervision.</a:t>
-            </a:r>
-          </a:p>
-        </p:txBody>
-      </p:sp>
-      <p:sp>
-        <p:nvSpPr>
-          <p:cNvPr id="4" name="text-49">
+              <a:t>Firebase: hosting, sign-in, and storage.</a:t>
+            </a:r>
+          </a:p>
+          <a:p xmlns:a="http://schemas.openxmlformats.org/drawingml/2006/main">
+            <a:pPr>
+              <a:defRPr sz="2025" b="0">
+                <a:solidFill>
+                  <a:srgbClr val="FFFFFF"/>
+                </a:solidFill>
+                <a:latin typeface="Noto Sans"/>
+                <a:ea typeface="Noto Sans"/>
+                <a:cs typeface="Noto Sans"/>
+              </a:defRPr>
+            </a:pPr>
+            <a:r>
+              <a:rPr sz="2025" b="0">
+                <a:solidFill>
+                  <a:srgbClr val="FFFFFF"/>
+                </a:solidFill>
+                <a:latin typeface="Noto Sans"/>
+                <a:ea typeface="Noto Sans"/>
+                <a:cs typeface="Noto Sans"/>
+              </a:rPr>
+              <a:t>57 live Firebase checks passed.</a:t>
+            </a:r>
+          </a:p>
+          <a:p xmlns:a="http://schemas.openxmlformats.org/drawingml/2006/main">
+            <a:pPr>
+              <a:defRPr sz="2025" b="0">
+                <a:solidFill>
+                  <a:srgbClr val="FFFFFF"/>
+                </a:solidFill>
+                <a:latin typeface="Noto Sans"/>
+                <a:ea typeface="Noto Sans"/>
+                <a:cs typeface="Noto Sans"/>
+              </a:defRPr>
+            </a:pPr>
+            <a:r>
+              <a:rPr sz="2025" b="0">
+                <a:solidFill>
+                  <a:srgbClr val="FFFFFF"/>
+                </a:solidFill>
+                <a:latin typeface="Noto Sans"/>
+                <a:ea typeface="Noto Sans"/>
+                <a:cs typeface="Noto Sans"/>
+              </a:rPr>
+              <a:t>Owner isolation and persistence verified.</a:t>
+            </a:r>
+          </a:p>
+        </p:txBody>
+      </p:sp>
+      <p:sp>
+        <p:nvSpPr>
+          <p:cNvPr id="4" name="text-48">
             <a:extLst xmlns:a="http://schemas.openxmlformats.org/drawingml/2006/main">
               <a:ext uri="{FF2B5EF4-FFF2-40B4-BE49-F238E27FC236}">
-                <a16:creationId xmlns:a16="http://schemas.microsoft.com/office/drawing/2014/main" id="{3AD313BB-F367-415A-8104-979F483B2226}"/>
+                <a16:creationId xmlns:a16="http://schemas.microsoft.com/office/drawing/2014/main" id="{19D194C3-7F02-47F7-A4F9-FF7D812F4B3E}"/>
               </a:ext>
             </a:extLst>
           </p:cNvPr>
@@ -4801,8 +4904,8 @@
         </p:nvSpPr>
         <p:spPr>
           <a:xfrm xmlns:a="http://schemas.openxmlformats.org/drawingml/2006/main">
-            <a:off x="685800" y="4810125"/>
-            <a:ext cx="10668000" cy="819150"/>
+            <a:off x="6553200" y="2124075"/>
+            <a:ext cx="4953000" cy="723900"/>
           </a:xfrm>
           <a:prstGeom xmlns:a="http://schemas.openxmlformats.org/drawingml/2006/main" prst="rect">
             <a:avLst/>
@@ -4819,58 +4922,35 @@
           <a:lstStyle xmlns:a="http://schemas.openxmlformats.org/drawingml/2006/main"/>
           <a:p xmlns:a="http://schemas.openxmlformats.org/drawingml/2006/main">
             <a:pPr>
-              <a:defRPr sz="1800" b="0">
-                <a:solidFill>
-                  <a:srgbClr val="DCE4EF"/>
-                </a:solidFill>
-                <a:latin typeface="Noto Sans"/>
-                <a:ea typeface="Noto Sans"/>
-                <a:cs typeface="Noto Sans"/>
-              </a:defRPr>
-            </a:pPr>
-            <a:r>
-              <a:rPr sz="1800" b="0">
-                <a:solidFill>
-                  <a:srgbClr val="DCE4EF"/>
-                </a:solidFill>
-                <a:latin typeface="Noto Sans"/>
-                <a:ea typeface="Noto Sans"/>
-                <a:cs typeface="Noto Sans"/>
-              </a:rPr>
-              <a:t>MVP for synthetic demonstration.</a:t>
-            </a:r>
-          </a:p>
-          <a:p xmlns:a="http://schemas.openxmlformats.org/drawingml/2006/main">
-            <a:pPr>
-              <a:defRPr sz="1800" b="0">
-                <a:solidFill>
-                  <a:srgbClr val="DCE4EF"/>
-                </a:solidFill>
-                <a:latin typeface="Noto Sans"/>
-                <a:ea typeface="Noto Sans"/>
-                <a:cs typeface="Noto Sans"/>
-              </a:defRPr>
-            </a:pPr>
-            <a:r>
-              <a:rPr sz="1800" b="0">
-                <a:solidFill>
-                  <a:srgbClr val="DCE4EF"/>
-                </a:solidFill>
-                <a:latin typeface="Noto Sans"/>
-                <a:ea typeface="Noto Sans"/>
-                <a:cs typeface="Noto Sans"/>
-              </a:rPr>
-              <a:t>No clinical validation, EHR integration, or proven health benefit.</a:t>
-            </a:r>
-          </a:p>
-        </p:txBody>
-      </p:sp>
-      <p:sp>
-        <p:nvSpPr>
-          <p:cNvPr id="5" name="text-50">
+              <a:defRPr sz="2325" b="1">
+                <a:solidFill>
+                  <a:srgbClr val="C7F578"/>
+                </a:solidFill>
+                <a:latin typeface="Noto Sans"/>
+                <a:ea typeface="Noto Sans"/>
+                <a:cs typeface="Noto Sans"/>
+              </a:defRPr>
+            </a:pPr>
+            <a:r>
+              <a:rPr sz="2325" b="1">
+                <a:solidFill>
+                  <a:srgbClr val="C7F578"/>
+                </a:solidFill>
+                <a:latin typeface="Noto Sans"/>
+                <a:ea typeface="Noto Sans"/>
+                <a:cs typeface="Noto Sans"/>
+              </a:rPr>
+              <a:t>What the pilot must measure</a:t>
+            </a:r>
+          </a:p>
+        </p:txBody>
+      </p:sp>
+      <p:sp>
+        <p:nvSpPr>
+          <p:cNvPr id="5" name="text-49">
             <a:extLst xmlns:a="http://schemas.openxmlformats.org/drawingml/2006/main">
               <a:ext uri="{FF2B5EF4-FFF2-40B4-BE49-F238E27FC236}">
-                <a16:creationId xmlns:a16="http://schemas.microsoft.com/office/drawing/2014/main" id="{A0BC45BF-03AD-4322-ABA3-A9B8240706B0}"/>
+                <a16:creationId xmlns:a16="http://schemas.microsoft.com/office/drawing/2014/main" id="{FE788521-F2B6-4465-A9A4-BA621C182B71}"/>
               </a:ext>
             </a:extLst>
           </p:cNvPr>
@@ -4881,8 +4961,8 @@
         </p:nvSpPr>
         <p:spPr>
           <a:xfrm xmlns:a="http://schemas.openxmlformats.org/drawingml/2006/main">
-            <a:off x="685800" y="6000750"/>
-            <a:ext cx="8096250" cy="381000"/>
+            <a:off x="6553200" y="3019425"/>
+            <a:ext cx="4953000" cy="1657350"/>
           </a:xfrm>
           <a:prstGeom xmlns:a="http://schemas.openxmlformats.org/drawingml/2006/main" prst="rect">
             <a:avLst/>
@@ -4899,7 +4979,167 @@
           <a:lstStyle xmlns:a="http://schemas.openxmlformats.org/drawingml/2006/main"/>
           <a:p xmlns:a="http://schemas.openxmlformats.org/drawingml/2006/main">
             <a:pPr>
-              <a:defRPr sz="1800" b="1">
+              <a:defRPr sz="2025" b="0">
+                <a:solidFill>
+                  <a:srgbClr val="FFFFFF"/>
+                </a:solidFill>
+                <a:latin typeface="Noto Sans"/>
+                <a:ea typeface="Noto Sans"/>
+                <a:cs typeface="Noto Sans"/>
+              </a:defRPr>
+            </a:pPr>
+            <a:r>
+              <a:rPr sz="2025" b="0">
+                <a:solidFill>
+                  <a:srgbClr val="FFFFFF"/>
+                </a:solidFill>
+                <a:latin typeface="Noto Sans"/>
+                <a:ea typeface="Noto Sans"/>
+                <a:cs typeface="Noto Sans"/>
+              </a:rPr>
+              <a:t>Missed actions and corrections.</a:t>
+            </a:r>
+          </a:p>
+          <a:p xmlns:a="http://schemas.openxmlformats.org/drawingml/2006/main">
+            <a:pPr>
+              <a:defRPr sz="2025" b="0">
+                <a:solidFill>
+                  <a:srgbClr val="FFFFFF"/>
+                </a:solidFill>
+                <a:latin typeface="Noto Sans"/>
+                <a:ea typeface="Noto Sans"/>
+                <a:cs typeface="Noto Sans"/>
+              </a:defRPr>
+            </a:pPr>
+            <a:r>
+              <a:rPr sz="2025" b="0">
+                <a:solidFill>
+                  <a:srgbClr val="FFFFFF"/>
+                </a:solidFill>
+                <a:latin typeface="Noto Sans"/>
+                <a:ea typeface="Noto Sans"/>
+                <a:cs typeface="Noto Sans"/>
+              </a:rPr>
+              <a:t>Preparation time and review burden.</a:t>
+            </a:r>
+          </a:p>
+          <a:p xmlns:a="http://schemas.openxmlformats.org/drawingml/2006/main">
+            <a:pPr>
+              <a:defRPr sz="2025" b="0">
+                <a:solidFill>
+                  <a:srgbClr val="FFFFFF"/>
+                </a:solidFill>
+                <a:latin typeface="Noto Sans"/>
+                <a:ea typeface="Noto Sans"/>
+                <a:cs typeface="Noto Sans"/>
+              </a:defRPr>
+            </a:pPr>
+            <a:r>
+              <a:rPr sz="2025" b="0">
+                <a:solidFill>
+                  <a:srgbClr val="FFFFFF"/>
+                </a:solidFill>
+                <a:latin typeface="Noto Sans"/>
+                <a:ea typeface="Noto Sans"/>
+                <a:cs typeface="Noto Sans"/>
+              </a:rPr>
+              <a:t>Reported follow-up resolution.</a:t>
+            </a:r>
+          </a:p>
+        </p:txBody>
+      </p:sp>
+      <p:sp>
+        <p:nvSpPr>
+          <p:cNvPr id="6" name="text-50">
+            <a:extLst xmlns:a="http://schemas.openxmlformats.org/drawingml/2006/main">
+              <a:ext uri="{FF2B5EF4-FFF2-40B4-BE49-F238E27FC236}">
+                <a16:creationId xmlns:a16="http://schemas.microsoft.com/office/drawing/2014/main" id="{C58597F9-CC88-429B-A799-A28F32B19429}"/>
+              </a:ext>
+            </a:extLst>
+          </p:cNvPr>
+          <p:cNvSpPr>
+            <a:spLocks xmlns:a="http://schemas.openxmlformats.org/drawingml/2006/main" noGrp="1"/>
+          </p:cNvSpPr>
+          <p:nvPr/>
+        </p:nvSpPr>
+        <p:spPr>
+          <a:xfrm xmlns:a="http://schemas.openxmlformats.org/drawingml/2006/main">
+            <a:off x="685800" y="4886325"/>
+            <a:ext cx="10820400" cy="723900"/>
+          </a:xfrm>
+          <a:prstGeom xmlns:a="http://schemas.openxmlformats.org/drawingml/2006/main" prst="rect">
+            <a:avLst/>
+          </a:prstGeom>
+          <a:noFill xmlns:a="http://schemas.openxmlformats.org/drawingml/2006/main"/>
+          <a:ln xmlns:a="http://schemas.openxmlformats.org/drawingml/2006/main" w="0">
+            <a:noFill/>
+          </a:ln>
+        </p:spPr>
+        <p:txBody>
+          <a:bodyPr xmlns:a="http://schemas.openxmlformats.org/drawingml/2006/main" wrap="square" lIns="0" tIns="0" rIns="0" bIns="0" anchor="t">
+            <a:noAutofit/>
+          </a:bodyPr>
+          <a:lstStyle xmlns:a="http://schemas.openxmlformats.org/drawingml/2006/main"/>
+          <a:p xmlns:a="http://schemas.openxmlformats.org/drawingml/2006/main">
+            <a:pPr>
+              <a:defRPr sz="1725" b="0">
+                <a:solidFill>
+                  <a:srgbClr val="DCE4EF"/>
+                </a:solidFill>
+                <a:latin typeface="Noto Sans"/>
+                <a:ea typeface="Noto Sans"/>
+                <a:cs typeface="Noto Sans"/>
+              </a:defRPr>
+            </a:pPr>
+            <a:r>
+              <a:rPr sz="1725" b="0">
+                <a:solidFill>
+                  <a:srgbClr val="DCE4EF"/>
+                </a:solidFill>
+                <a:latin typeface="Noto Sans"/>
+                <a:ea typeface="Noto Sans"/>
+                <a:cs typeface="Noto Sans"/>
+              </a:rPr>
+              <a:t>Prototype tested with synthetic data. No clinical validation or proven health benefit.</a:t>
+            </a:r>
+          </a:p>
+        </p:txBody>
+      </p:sp>
+      <p:sp>
+        <p:nvSpPr>
+          <p:cNvPr id="7" name="text-51">
+            <a:extLst xmlns:a="http://schemas.openxmlformats.org/drawingml/2006/main">
+              <a:ext uri="{FF2B5EF4-FFF2-40B4-BE49-F238E27FC236}">
+                <a16:creationId xmlns:a16="http://schemas.microsoft.com/office/drawing/2014/main" id="{9AC18409-5316-4B26-8F2D-CED28B0A6514}"/>
+              </a:ext>
+            </a:extLst>
+          </p:cNvPr>
+          <p:cNvSpPr>
+            <a:spLocks xmlns:a="http://schemas.openxmlformats.org/drawingml/2006/main" noGrp="1"/>
+          </p:cNvSpPr>
+          <p:nvPr/>
+        </p:nvSpPr>
+        <p:spPr>
+          <a:xfrm xmlns:a="http://schemas.openxmlformats.org/drawingml/2006/main">
+            <a:off x="685800" y="5791200"/>
+            <a:ext cx="10001250" cy="352425"/>
+          </a:xfrm>
+          <a:prstGeom xmlns:a="http://schemas.openxmlformats.org/drawingml/2006/main" prst="rect">
+            <a:avLst/>
+          </a:prstGeom>
+          <a:noFill xmlns:a="http://schemas.openxmlformats.org/drawingml/2006/main"/>
+          <a:ln xmlns:a="http://schemas.openxmlformats.org/drawingml/2006/main" w="0">
+            <a:noFill/>
+          </a:ln>
+        </p:spPr>
+        <p:txBody>
+          <a:bodyPr xmlns:a="http://schemas.openxmlformats.org/drawingml/2006/main" wrap="square" lIns="0" tIns="0" rIns="0" bIns="0" anchor="t">
+            <a:noAutofit/>
+          </a:bodyPr>
+          <a:lstStyle xmlns:a="http://schemas.openxmlformats.org/drawingml/2006/main"/>
+          <a:p xmlns:a="http://schemas.openxmlformats.org/drawingml/2006/main">
+            <a:pPr>
+              <a:defRPr sz="2100" b="1">
                 <a:solidFill>
                   <a:srgbClr val="C7F578"/>
                 </a:solidFill>
@@ -4909,9 +5149,66 @@
               </a:defRPr>
             </a:pPr>
             <a:r>
-              <a:rPr sz="1800" b="1">
+              <a:rPr sz="2100" b="1">
                 <a:solidFill>
                   <a:srgbClr val="C7F578"/>
+                </a:solidFill>
+                <a:latin typeface="Noto Sans"/>
+                <a:ea typeface="Noto Sans"/>
+                <a:cs typeface="Noto Sans"/>
+              </a:rPr>
+              <a:t>looplight-care.web.app</a:t>
+            </a:r>
+          </a:p>
+        </p:txBody>
+      </p:sp>
+      <p:sp>
+        <p:nvSpPr>
+          <p:cNvPr id="8" name="text-52">
+            <a:extLst xmlns:a="http://schemas.openxmlformats.org/drawingml/2006/main">
+              <a:ext uri="{FF2B5EF4-FFF2-40B4-BE49-F238E27FC236}">
+                <a16:creationId xmlns:a16="http://schemas.microsoft.com/office/drawing/2014/main" id="{F09CE463-40D9-4AD2-BFCF-492C8F3A06A8}"/>
+              </a:ext>
+            </a:extLst>
+          </p:cNvPr>
+          <p:cNvSpPr>
+            <a:spLocks xmlns:a="http://schemas.openxmlformats.org/drawingml/2006/main" noGrp="1"/>
+          </p:cNvSpPr>
+          <p:nvPr/>
+        </p:nvSpPr>
+        <p:spPr>
+          <a:xfrm xmlns:a="http://schemas.openxmlformats.org/drawingml/2006/main">
+            <a:off x="685800" y="6210300"/>
+            <a:ext cx="10001250" cy="276225"/>
+          </a:xfrm>
+          <a:prstGeom xmlns:a="http://schemas.openxmlformats.org/drawingml/2006/main" prst="rect">
+            <a:avLst/>
+          </a:prstGeom>
+          <a:noFill xmlns:a="http://schemas.openxmlformats.org/drawingml/2006/main"/>
+          <a:ln xmlns:a="http://schemas.openxmlformats.org/drawingml/2006/main" w="0">
+            <a:noFill/>
+          </a:ln>
+        </p:spPr>
+        <p:txBody>
+          <a:bodyPr xmlns:a="http://schemas.openxmlformats.org/drawingml/2006/main" wrap="square" lIns="0" tIns="0" rIns="0" bIns="0" anchor="t">
+            <a:noAutofit/>
+          </a:bodyPr>
+          <a:lstStyle xmlns:a="http://schemas.openxmlformats.org/drawingml/2006/main"/>
+          <a:p xmlns:a="http://schemas.openxmlformats.org/drawingml/2006/main">
+            <a:pPr>
+              <a:defRPr sz="1500" b="0">
+                <a:solidFill>
+                  <a:srgbClr val="DCE4EF"/>
+                </a:solidFill>
+                <a:latin typeface="Noto Sans"/>
+                <a:ea typeface="Noto Sans"/>
+                <a:cs typeface="Noto Sans"/>
+              </a:defRPr>
+            </a:pPr>
+            <a:r>
+              <a:rPr sz="1500" b="0">
+                <a:solidFill>
+                  <a:srgbClr val="DCE4EF"/>
                 </a:solidFill>
                 <a:latin typeface="Noto Sans"/>
                 <a:ea typeface="Noto Sans"/>
@@ -4925,7 +5222,7 @@
     </p:spTree>
     <p:extLst>
       <p:ext uri="{BB962C8B-B14F-4D97-AF65-F5344CB8AC3E}">
-        <p14:creationId xmlns:p14="http://schemas.microsoft.com/office/powerpoint/2010/main" val="659711056"/>
+        <p14:creationId xmlns:p14="http://schemas.microsoft.com/office/powerpoint/2010/main" val="102156178"/>
       </p:ext>
     </p:extLst>
   </p:cSld>

</xml_diff>